<commit_message>
Adopt committee-approved poster design as the sole official template
Replace the old boxed-header LaTeX design with the accepted revision
(boxless header flanked by logos, borderless-title section cards,
optional funding-logo footer), rewrite the PPTX to match it, and
update the README's authoring rules accordingly.

Co-Authored-By: Claude Sonnet 5 <noreply@anthropic.com>
</commit_message>
<xml_diff>
--- a/pptx/solabima2026_poster_template.pptx
+++ b/pptx/solabima2026_poster_template.pptx
@@ -3090,23 +3090,264 @@
       <p:grpSpPr/>
       <p:sp>
         <p:nvSpPr>
-          <p:cNvPr id="2" name="Rectangle 1"/>
-          <p:cNvSpPr/>
+          <p:cNvPr id="2" name="TextBox 1"/>
+          <p:cNvSpPr txBox="1"/>
           <p:nvPr/>
         </p:nvSpPr>
         <p:spPr>
           <a:xfrm>
-            <a:off x="0" y="0"/>
-            <a:ext cx="30276000" cy="5400000"/>
+            <a:off x="4919400" y="720000"/>
+            <a:ext cx="20437200" cy="2700000"/>
           </a:xfrm>
           <a:prstGeom prst="rect">
             <a:avLst/>
           </a:prstGeom>
+          <a:noFill/>
+        </p:spPr>
+        <p:txBody>
+          <a:bodyPr wrap="square" anchor="t">
+            <a:spAutoFit/>
+          </a:bodyPr>
+          <a:lstStyle/>
+          <a:p>
+            <a:pPr algn="ctr">
+              <a:lnSpc>
+                <a:spcPct val="115000"/>
+              </a:lnSpc>
+            </a:pPr>
+            <a:r>
+              <a:rPr sz="5800" b="1" i="0">
+                <a:solidFill>
+                  <a:srgbClr val="1C6EA8"/>
+                </a:solidFill>
+                <a:latin typeface="Arial"/>
+              </a:rPr>
+              <a:t>TÍTULO DEL TRABAJO EN MAYÚSCULAS</a:t>
+            </a:r>
+          </a:p>
+        </p:txBody>
+      </p:sp>
+      <p:sp>
+        <p:nvSpPr>
+          <p:cNvPr id="3" name="TextBox 2"/>
+          <p:cNvSpPr txBox="1"/>
+          <p:nvPr/>
+        </p:nvSpPr>
+        <p:spPr>
+          <a:xfrm>
+            <a:off x="4919400" y="3708000"/>
+            <a:ext cx="20437200" cy="936000"/>
+          </a:xfrm>
+          <a:prstGeom prst="rect">
+            <a:avLst/>
+          </a:prstGeom>
+          <a:noFill/>
+        </p:spPr>
+        <p:txBody>
+          <a:bodyPr wrap="square">
+            <a:spAutoFit/>
+          </a:bodyPr>
+          <a:lstStyle/>
+          <a:p>
+            <a:pPr algn="ctr">
+              <a:lnSpc>
+                <a:spcPct val="115000"/>
+              </a:lnSpc>
+            </a:pPr>
+            <a:r>
+              <a:rPr sz="3000" b="1" i="0">
+                <a:solidFill>
+                  <a:srgbClr val="C2661F"/>
+                </a:solidFill>
+                <a:latin typeface="Arial"/>
+              </a:rPr>
+              <a:t>Subtítulo opcional</a:t>
+            </a:r>
+          </a:p>
+        </p:txBody>
+      </p:sp>
+      <p:sp>
+        <p:nvSpPr>
+          <p:cNvPr id="4" name="TextBox 3"/>
+          <p:cNvSpPr txBox="1"/>
+          <p:nvPr/>
+        </p:nvSpPr>
+        <p:spPr>
+          <a:xfrm>
+            <a:off x="4919400" y="5148000"/>
+            <a:ext cx="20437200" cy="792000"/>
+          </a:xfrm>
+          <a:prstGeom prst="rect">
+            <a:avLst/>
+          </a:prstGeom>
+          <a:noFill/>
+        </p:spPr>
+        <p:txBody>
+          <a:bodyPr wrap="square">
+            <a:spAutoFit/>
+          </a:bodyPr>
+          <a:lstStyle/>
+          <a:p>
+            <a:pPr algn="ctr">
+              <a:lnSpc>
+                <a:spcPct val="115000"/>
+              </a:lnSpc>
+            </a:pPr>
+            <a:r>
+              <a:rPr sz="2400" b="0" i="0">
+                <a:solidFill>
+                  <a:srgbClr val="333333"/>
+                </a:solidFill>
+                <a:latin typeface="Georgia"/>
+              </a:rPr>
+              <a:t>Nombre Apellido¹, Nombre Apellido², Nombre Apellido¹,*</a:t>
+            </a:r>
+          </a:p>
+        </p:txBody>
+      </p:sp>
+      <p:sp>
+        <p:nvSpPr>
+          <p:cNvPr id="5" name="TextBox 4"/>
+          <p:cNvSpPr txBox="1"/>
+          <p:nvPr/>
+        </p:nvSpPr>
+        <p:spPr>
+          <a:xfrm>
+            <a:off x="4919400" y="6300000"/>
+            <a:ext cx="20437200" cy="1620000"/>
+          </a:xfrm>
+          <a:prstGeom prst="rect">
+            <a:avLst/>
+          </a:prstGeom>
+          <a:noFill/>
+        </p:spPr>
+        <p:txBody>
+          <a:bodyPr wrap="square">
+            <a:spAutoFit/>
+          </a:bodyPr>
+          <a:lstStyle/>
+          <a:p>
+            <a:pPr algn="ctr">
+              <a:lnSpc>
+                <a:spcPct val="115000"/>
+              </a:lnSpc>
+            </a:pPr>
+            <a:r>
+              <a:rPr sz="1800" b="0" i="0">
+                <a:solidFill>
+                  <a:srgbClr val="333333"/>
+                </a:solidFill>
+                <a:latin typeface="Georgia"/>
+              </a:rPr>
+              <a:t>¹Facultad de Ciencias Imaginarias, Universidad de Algún Lugar, País</a:t>
+            </a:r>
+          </a:p>
+          <a:p>
+            <a:pPr algn="ctr">
+              <a:lnSpc>
+                <a:spcPct val="115000"/>
+              </a:lnSpc>
+            </a:pPr>
+            <a:r>
+              <a:rPr sz="1800" b="0" i="0">
+                <a:solidFill>
+                  <a:srgbClr val="333333"/>
+                </a:solidFill>
+                <a:latin typeface="Georgia"/>
+              </a:rPr>
+              <a:t>²Instituto de Ejemplos Genéricos, Ciudad Ficticia</a:t>
+            </a:r>
+          </a:p>
+          <a:p>
+            <a:pPr algn="ctr">
+              <a:lnSpc>
+                <a:spcPct val="115000"/>
+              </a:lnSpc>
+            </a:pPr>
+            <a:r>
+              <a:rPr sz="1800" b="0" i="0">
+                <a:solidFill>
+                  <a:srgbClr val="333333"/>
+                </a:solidFill>
+                <a:latin typeface="Georgia"/>
+              </a:rPr>
+              <a:t>*Autor de correspondencia: correo@ejemplo.py</a:t>
+            </a:r>
+          </a:p>
+        </p:txBody>
+      </p:sp>
+      <p:pic>
+        <p:nvPicPr>
+          <p:cNvPr id="6" name="Picture 5" descr="logo_solabima_badge.png"/>
+          <p:cNvPicPr>
+            <a:picLocks noChangeAspect="1"/>
+          </p:cNvPicPr>
+          <p:nvPr/>
+        </p:nvPicPr>
+        <p:blipFill>
+          <a:blip r:embed="rId2"/>
+          <a:stretch>
+            <a:fillRect/>
+          </a:stretch>
+        </p:blipFill>
+        <p:spPr>
+          <a:xfrm>
+            <a:off x="832200" y="2250000"/>
+            <a:ext cx="3795000" cy="4140000"/>
+          </a:xfrm>
+          <a:prstGeom prst="rect">
+            <a:avLst/>
+          </a:prstGeom>
+        </p:spPr>
+      </p:pic>
+      <p:pic>
+        <p:nvPicPr>
+          <p:cNvPr id="7" name="Picture 6" descr="logo_header_right.png"/>
+          <p:cNvPicPr>
+            <a:picLocks noChangeAspect="1"/>
+          </p:cNvPicPr>
+          <p:nvPr/>
+        </p:nvPicPr>
+        <p:blipFill>
+          <a:blip r:embed="rId3"/>
+          <a:stretch>
+            <a:fillRect/>
+          </a:stretch>
+        </p:blipFill>
+        <p:spPr>
+          <a:xfrm>
+            <a:off x="25633800" y="2970000"/>
+            <a:ext cx="3825000" cy="2700000"/>
+          </a:xfrm>
+          <a:prstGeom prst="rect">
+            <a:avLst/>
+          </a:prstGeom>
+        </p:spPr>
+      </p:pic>
+      <p:sp>
+        <p:nvSpPr>
+          <p:cNvPr id="8" name="Round Diagonal Corner Rectangle 7"/>
+          <p:cNvSpPr/>
+          <p:nvPr/>
+        </p:nvSpPr>
+        <p:spPr>
+          <a:xfrm>
+            <a:off x="540000" y="8820000"/>
+            <a:ext cx="14148000" cy="7740000"/>
+          </a:xfrm>
+          <a:prstGeom prst="round2DiagRect">
+            <a:avLst>
+              <a:gd name="adj1" fmla="val 3255"/>
+              <a:gd name="adj2" fmla="val 3255"/>
+            </a:avLst>
+          </a:prstGeom>
           <a:solidFill>
-            <a:srgbClr val="003B49"/>
+            <a:srgbClr val="FFFFFF"/>
           </a:solidFill>
-          <a:ln>
-            <a:noFill/>
+          <a:ln w="25400">
+            <a:solidFill>
+              <a:srgbClr val="F7C59F"/>
+            </a:solidFill>
           </a:ln>
           <a:effectLst/>
         </p:spPr>
@@ -3134,14 +3375,14 @@
       </p:sp>
       <p:sp>
         <p:nvSpPr>
-          <p:cNvPr id="3" name="TextBox 2"/>
+          <p:cNvPr id="9" name="TextBox 8"/>
           <p:cNvSpPr txBox="1"/>
           <p:nvPr/>
         </p:nvSpPr>
         <p:spPr>
           <a:xfrm>
-            <a:off x="900000" y="720000"/>
-            <a:ext cx="28476000" cy="1260000"/>
+            <a:off x="1044000" y="9324000"/>
+            <a:ext cx="13140000" cy="720000"/>
           </a:xfrm>
           <a:prstGeom prst="rect">
             <a:avLst/>
@@ -3154,33 +3395,33 @@
           </a:bodyPr>
           <a:lstStyle/>
           <a:p>
-            <a:pPr algn="ctr">
+            <a:pPr algn="l">
               <a:lnSpc>
                 <a:spcPct val="115000"/>
               </a:lnSpc>
             </a:pPr>
             <a:r>
-              <a:rPr sz="5400" b="1" i="0">
-                <a:solidFill>
-                  <a:srgbClr val="FFFFFF"/>
-                </a:solidFill>
-                <a:latin typeface="Georgia"/>
+              <a:rPr sz="2800" b="1" i="0">
+                <a:solidFill>
+                  <a:srgbClr val="1C6EA8"/>
+                </a:solidFill>
+                <a:latin typeface="Arial"/>
               </a:rPr>
-              <a:t>TITULO DEL TRABAJO EN MAYUSCULAS</a:t>
-            </a:r>
-          </a:p>
-        </p:txBody>
-      </p:sp>
-      <p:sp>
-        <p:nvSpPr>
-          <p:cNvPr id="4" name="TextBox 3"/>
+              <a:t>Motivación / Introducción</a:t>
+            </a:r>
+          </a:p>
+        </p:txBody>
+      </p:sp>
+      <p:sp>
+        <p:nvSpPr>
+          <p:cNvPr id="10" name="TextBox 9"/>
           <p:cNvSpPr txBox="1"/>
           <p:nvPr/>
         </p:nvSpPr>
         <p:spPr>
           <a:xfrm>
-            <a:off x="900000" y="1980000"/>
-            <a:ext cx="28476000" cy="576000"/>
+            <a:off x="1044000" y="10260000"/>
+            <a:ext cx="13140000" cy="1260000"/>
           </a:xfrm>
           <a:prstGeom prst="rect">
             <a:avLst/>
@@ -3193,33 +3434,33 @@
           </a:bodyPr>
           <a:lstStyle/>
           <a:p>
-            <a:pPr algn="ctr">
+            <a:pPr algn="l">
               <a:lnSpc>
                 <a:spcPct val="115000"/>
               </a:lnSpc>
             </a:pPr>
             <a:r>
-              <a:rPr sz="2600" b="0" i="1">
-                <a:solidFill>
-                  <a:srgbClr val="FFFFFF"/>
+              <a:rPr sz="1600" b="0" i="0">
+                <a:solidFill>
+                  <a:srgbClr val="000000"/>
                 </a:solidFill>
                 <a:latin typeface="Georgia"/>
               </a:rPr>
-              <a:t>Subtitulo opcional</a:t>
-            </a:r>
-          </a:p>
-        </p:txBody>
-      </p:sp>
-      <p:sp>
-        <p:nvSpPr>
-          <p:cNvPr id="5" name="TextBox 4"/>
+              <a:t>Presente aquí el contexto y la motivación del trabajo: el problema abordado, su relevancia dentro de la biología matemática y los antecedentes más importantes.</a:t>
+            </a:r>
+          </a:p>
+        </p:txBody>
+      </p:sp>
+      <p:sp>
+        <p:nvSpPr>
+          <p:cNvPr id="11" name="TextBox 10"/>
           <p:cNvSpPr txBox="1"/>
           <p:nvPr/>
         </p:nvSpPr>
         <p:spPr>
           <a:xfrm>
-            <a:off x="900000" y="2772000"/>
-            <a:ext cx="28476000" cy="576000"/>
+            <a:off x="1044000" y="11628000"/>
+            <a:ext cx="13140000" cy="1620000"/>
           </a:xfrm>
           <a:prstGeom prst="rect">
             <a:avLst/>
@@ -3232,33 +3473,33 @@
           </a:bodyPr>
           <a:lstStyle/>
           <a:p>
-            <a:pPr algn="ctr">
+            <a:pPr algn="l">
               <a:lnSpc>
                 <a:spcPct val="115000"/>
               </a:lnSpc>
             </a:pPr>
             <a:r>
-              <a:rPr sz="2400" b="0" i="0">
-                <a:solidFill>
-                  <a:srgbClr val="FFFFFF"/>
+              <a:rPr sz="1600" b="0" i="0">
+                <a:solidFill>
+                  <a:srgbClr val="000000"/>
                 </a:solidFill>
                 <a:latin typeface="Georgia"/>
               </a:rPr>
-              <a:t>Nombre Apellido¹, Nombre Apellido², Nombre Apellido¹,*</a:t>
-            </a:r>
-          </a:p>
-        </p:txBody>
-      </p:sp>
-      <p:sp>
-        <p:nvSpPr>
-          <p:cNvPr id="6" name="TextBox 5"/>
+              <a:t>Lorem ipsum dolor sit amet, consectetur adipiscing elit, sed do eiusmod tempor incididunt ut labore et dolore magna aliqua. Ut enim ad minim veniam, quis nostrud exercitation ullamco laboris nisi ut aliquip ex ea commodo consequat.</a:t>
+            </a:r>
+          </a:p>
+        </p:txBody>
+      </p:sp>
+      <p:sp>
+        <p:nvSpPr>
+          <p:cNvPr id="12" name="TextBox 11"/>
           <p:cNvSpPr txBox="1"/>
           <p:nvPr/>
         </p:nvSpPr>
         <p:spPr>
           <a:xfrm>
-            <a:off x="900000" y="3600000"/>
-            <a:ext cx="28476000" cy="1440000"/>
+            <a:off x="1044000" y="13428000"/>
+            <a:ext cx="13140000" cy="2628000"/>
           </a:xfrm>
           <a:prstGeom prst="rect">
             <a:avLst/>
@@ -3271,59 +3512,126 @@
           </a:bodyPr>
           <a:lstStyle/>
           <a:p>
-            <a:pPr algn="ctr">
+            <a:pPr algn="l" marL="285750" indent="-285750">
               <a:lnSpc>
                 <a:spcPct val="115000"/>
               </a:lnSpc>
+              <a:spcAft>
+                <a:spcPts val="800"/>
+              </a:spcAft>
+              <a:buClr>
+                <a:srgbClr val="F19651"/>
+              </a:buClr>
+              <a:buFont typeface="Georgia"/>
+              <a:buChar char="•"/>
             </a:pPr>
             <a:r>
-              <a:rPr sz="1800" b="0" i="0">
-                <a:solidFill>
-                  <a:srgbClr val="FFFFFF"/>
-                </a:solidFill>
-                <a:latin typeface="Arial"/>
+              <a:rPr sz="1600">
+                <a:solidFill>
+                  <a:srgbClr val="000000"/>
+                </a:solidFill>
+                <a:latin typeface="Georgia"/>
               </a:rPr>
-              <a:t>¹Facultad Politecnica, Universidad Nacional de Asuncion (FPUNA), Paraguay    ²Institucion / Departamento</a:t>
-            </a:r>
-          </a:p>
-          <a:p>
-            <a:pPr algn="ctr">
+              <a:t>Antecedente o dato relevante 1.</a:t>
+            </a:r>
+          </a:p>
+          <a:p>
+            <a:pPr algn="l" marL="285750" indent="-285750">
               <a:lnSpc>
                 <a:spcPct val="115000"/>
               </a:lnSpc>
+              <a:spcAft>
+                <a:spcPts val="800"/>
+              </a:spcAft>
+              <a:buClr>
+                <a:srgbClr val="F19651"/>
+              </a:buClr>
+              <a:buFont typeface="Georgia"/>
+              <a:buChar char="•"/>
             </a:pPr>
             <a:r>
-              <a:rPr sz="1800" b="0" i="0">
-                <a:solidFill>
-                  <a:srgbClr val="FFFFFF"/>
-                </a:solidFill>
-                <a:latin typeface="Arial"/>
+              <a:rPr sz="1600">
+                <a:solidFill>
+                  <a:srgbClr val="000000"/>
+                </a:solidFill>
+                <a:latin typeface="Georgia"/>
               </a:rPr>
-              <a:t>*Autor de correspondencia: correo@ejemplo.py</a:t>
-            </a:r>
-          </a:p>
-        </p:txBody>
-      </p:sp>
-      <p:sp>
-        <p:nvSpPr>
-          <p:cNvPr id="7" name="Rectangle 6"/>
+              <a:t>Antecedente o dato relevante 2.</a:t>
+            </a:r>
+          </a:p>
+          <a:p>
+            <a:pPr algn="l" marL="285750" indent="-285750">
+              <a:lnSpc>
+                <a:spcPct val="115000"/>
+              </a:lnSpc>
+              <a:spcAft>
+                <a:spcPts val="800"/>
+              </a:spcAft>
+              <a:buClr>
+                <a:srgbClr val="F19651"/>
+              </a:buClr>
+              <a:buFont typeface="Georgia"/>
+              <a:buChar char="•"/>
+            </a:pPr>
+            <a:r>
+              <a:rPr sz="1600">
+                <a:solidFill>
+                  <a:srgbClr val="000000"/>
+                </a:solidFill>
+                <a:latin typeface="Georgia"/>
+              </a:rPr>
+              <a:t>Vacío de conocimiento que motiva este trabajo.</a:t>
+            </a:r>
+          </a:p>
+          <a:p>
+            <a:pPr algn="l" marL="285750" indent="-285750">
+              <a:lnSpc>
+                <a:spcPct val="115000"/>
+              </a:lnSpc>
+              <a:spcAft>
+                <a:spcPts val="800"/>
+              </a:spcAft>
+              <a:buClr>
+                <a:srgbClr val="F19651"/>
+              </a:buClr>
+              <a:buFont typeface="Georgia"/>
+              <a:buChar char="•"/>
+            </a:pPr>
+            <a:r>
+              <a:rPr sz="1600">
+                <a:solidFill>
+                  <a:srgbClr val="000000"/>
+                </a:solidFill>
+                <a:latin typeface="Georgia"/>
+              </a:rPr>
+              <a:t>Duis aute irure dolor in reprehenderit in voluptate velit esse cillum dolore eu fugiat nulla pariatur.</a:t>
+            </a:r>
+          </a:p>
+        </p:txBody>
+      </p:sp>
+      <p:sp>
+        <p:nvSpPr>
+          <p:cNvPr id="13" name="Round Diagonal Corner Rectangle 12"/>
           <p:cNvSpPr/>
           <p:nvPr/>
         </p:nvSpPr>
         <p:spPr>
           <a:xfrm>
-            <a:off x="900000" y="6300000"/>
-            <a:ext cx="13788000" cy="6840000"/>
-          </a:xfrm>
-          <a:prstGeom prst="rect">
-            <a:avLst/>
+            <a:off x="540000" y="17280000"/>
+            <a:ext cx="14148000" cy="4140000"/>
+          </a:xfrm>
+          <a:prstGeom prst="round2DiagRect">
+            <a:avLst>
+              <a:gd name="adj1" fmla="val 6086"/>
+              <a:gd name="adj2" fmla="val 6086"/>
+            </a:avLst>
           </a:prstGeom>
           <a:solidFill>
             <a:srgbClr val="FFFFFF"/>
           </a:solidFill>
           <a:ln w="25400">
             <a:solidFill>
-              <a:srgbClr val="003B49"/>
+              <a:srgbClr val="F7C59F"/>
             </a:solidFill>
           </a:ln>
           <a:effectLst/>
@@ -3352,24 +3660,161 @@
       </p:sp>
       <p:sp>
         <p:nvSpPr>
-          <p:cNvPr id="8" name="Rectangle 7"/>
-          <p:cNvSpPr/>
+          <p:cNvPr id="14" name="TextBox 13"/>
+          <p:cNvSpPr txBox="1"/>
           <p:nvPr/>
         </p:nvSpPr>
         <p:spPr>
           <a:xfrm>
-            <a:off x="900000" y="6300000"/>
-            <a:ext cx="13788000" cy="720000"/>
+            <a:off x="1044000" y="17784000"/>
+            <a:ext cx="13140000" cy="720000"/>
           </a:xfrm>
           <a:prstGeom prst="rect">
             <a:avLst/>
           </a:prstGeom>
+          <a:noFill/>
+        </p:spPr>
+        <p:txBody>
+          <a:bodyPr wrap="square">
+            <a:spAutoFit/>
+          </a:bodyPr>
+          <a:lstStyle/>
+          <a:p>
+            <a:pPr algn="l">
+              <a:lnSpc>
+                <a:spcPct val="115000"/>
+              </a:lnSpc>
+            </a:pPr>
+            <a:r>
+              <a:rPr sz="2800" b="1" i="0">
+                <a:solidFill>
+                  <a:srgbClr val="1C6EA8"/>
+                </a:solidFill>
+                <a:latin typeface="Arial"/>
+              </a:rPr>
+              <a:t>Objetivos</a:t>
+            </a:r>
+          </a:p>
+        </p:txBody>
+      </p:sp>
+      <p:sp>
+        <p:nvSpPr>
+          <p:cNvPr id="15" name="TextBox 14"/>
+          <p:cNvSpPr txBox="1"/>
+          <p:nvPr/>
+        </p:nvSpPr>
+        <p:spPr>
+          <a:xfrm>
+            <a:off x="1044000" y="18720000"/>
+            <a:ext cx="13140000" cy="2196000"/>
+          </a:xfrm>
+          <a:prstGeom prst="rect">
+            <a:avLst/>
+          </a:prstGeom>
+          <a:noFill/>
+        </p:spPr>
+        <p:txBody>
+          <a:bodyPr wrap="square">
+            <a:spAutoFit/>
+          </a:bodyPr>
+          <a:lstStyle/>
+          <a:p>
+            <a:pPr algn="l" marL="285750" indent="-285750">
+              <a:lnSpc>
+                <a:spcPct val="115000"/>
+              </a:lnSpc>
+              <a:spcAft>
+                <a:spcPts val="800"/>
+              </a:spcAft>
+              <a:buClr>
+                <a:srgbClr val="F19651"/>
+              </a:buClr>
+              <a:buFont typeface="Georgia"/>
+              <a:buChar char="•"/>
+            </a:pPr>
+            <a:r>
+              <a:rPr sz="1600">
+                <a:solidFill>
+                  <a:srgbClr val="000000"/>
+                </a:solidFill>
+                <a:latin typeface="Georgia"/>
+              </a:rPr>
+              <a:t>Objetivo general del trabajo.</a:t>
+            </a:r>
+          </a:p>
+          <a:p>
+            <a:pPr algn="l" marL="285750" indent="-285750">
+              <a:lnSpc>
+                <a:spcPct val="115000"/>
+              </a:lnSpc>
+              <a:spcAft>
+                <a:spcPts val="800"/>
+              </a:spcAft>
+              <a:buClr>
+                <a:srgbClr val="F19651"/>
+              </a:buClr>
+              <a:buFont typeface="Georgia"/>
+              <a:buChar char="•"/>
+            </a:pPr>
+            <a:r>
+              <a:rPr sz="1600">
+                <a:solidFill>
+                  <a:srgbClr val="000000"/>
+                </a:solidFill>
+                <a:latin typeface="Georgia"/>
+              </a:rPr>
+              <a:t>Objetivo específico 1.</a:t>
+            </a:r>
+          </a:p>
+          <a:p>
+            <a:pPr algn="l" marL="285750" indent="-285750">
+              <a:lnSpc>
+                <a:spcPct val="115000"/>
+              </a:lnSpc>
+              <a:spcAft>
+                <a:spcPts val="800"/>
+              </a:spcAft>
+              <a:buClr>
+                <a:srgbClr val="F19651"/>
+              </a:buClr>
+              <a:buFont typeface="Georgia"/>
+              <a:buChar char="•"/>
+            </a:pPr>
+            <a:r>
+              <a:rPr sz="1600">
+                <a:solidFill>
+                  <a:srgbClr val="000000"/>
+                </a:solidFill>
+                <a:latin typeface="Georgia"/>
+              </a:rPr>
+              <a:t>Objetivo específico 2.</a:t>
+            </a:r>
+          </a:p>
+        </p:txBody>
+      </p:sp>
+      <p:sp>
+        <p:nvSpPr>
+          <p:cNvPr id="16" name="Round Diagonal Corner Rectangle 15"/>
+          <p:cNvSpPr/>
+          <p:nvPr/>
+        </p:nvSpPr>
+        <p:spPr>
+          <a:xfrm>
+            <a:off x="540000" y="22140000"/>
+            <a:ext cx="14148000" cy="14400000"/>
+          </a:xfrm>
+          <a:prstGeom prst="round2DiagRect">
+            <a:avLst>
+              <a:gd name="adj1" fmla="val 1781"/>
+              <a:gd name="adj2" fmla="val 1781"/>
+            </a:avLst>
+          </a:prstGeom>
           <a:solidFill>
-            <a:srgbClr val="003B49"/>
+            <a:srgbClr val="FFFFFF"/>
           </a:solidFill>
           <a:ln w="25400">
             <a:solidFill>
-              <a:srgbClr val="003B49"/>
+              <a:srgbClr val="F7C59F"/>
             </a:solidFill>
           </a:ln>
           <a:effectLst/>
@@ -3398,14 +3843,14 @@
       </p:sp>
       <p:sp>
         <p:nvSpPr>
-          <p:cNvPr id="9" name="TextBox 8"/>
+          <p:cNvPr id="17" name="TextBox 16"/>
           <p:cNvSpPr txBox="1"/>
           <p:nvPr/>
         </p:nvSpPr>
         <p:spPr>
           <a:xfrm>
-            <a:off x="1260000" y="6300000"/>
-            <a:ext cx="13068000" cy="720000"/>
+            <a:off x="1044000" y="22644000"/>
+            <a:ext cx="13140000" cy="720000"/>
           </a:xfrm>
           <a:prstGeom prst="rect">
             <a:avLst/>
@@ -3413,7 +3858,7 @@
           <a:noFill/>
         </p:spPr>
         <p:txBody>
-          <a:bodyPr wrap="square" anchor="ctr">
+          <a:bodyPr wrap="square">
             <a:spAutoFit/>
           </a:bodyPr>
           <a:lstStyle/>
@@ -3424,27 +3869,27 @@
               </a:lnSpc>
             </a:pPr>
             <a:r>
-              <a:rPr sz="2600" b="1" i="0">
-                <a:solidFill>
-                  <a:srgbClr val="FFFFFF"/>
-                </a:solidFill>
-                <a:latin typeface="Georgia"/>
+              <a:rPr sz="2800" b="1" i="0">
+                <a:solidFill>
+                  <a:srgbClr val="1C6EA8"/>
+                </a:solidFill>
+                <a:latin typeface="Arial"/>
               </a:rPr>
-              <a:t>Motivacion / Introduccion</a:t>
-            </a:r>
-          </a:p>
-        </p:txBody>
-      </p:sp>
-      <p:sp>
-        <p:nvSpPr>
-          <p:cNvPr id="10" name="TextBox 9"/>
+              <a:t>Metodología</a:t>
+            </a:r>
+          </a:p>
+        </p:txBody>
+      </p:sp>
+      <p:sp>
+        <p:nvSpPr>
+          <p:cNvPr id="18" name="TextBox 17"/>
           <p:cNvSpPr txBox="1"/>
           <p:nvPr/>
         </p:nvSpPr>
         <p:spPr>
           <a:xfrm>
-            <a:off x="1260000" y="7380000"/>
-            <a:ext cx="13068000" cy="2160000"/>
+            <a:off x="1044000" y="23580000"/>
+            <a:ext cx="13140000" cy="1008000"/>
           </a:xfrm>
           <a:prstGeom prst="rect">
             <a:avLst/>
@@ -3463,27 +3908,27 @@
               </a:lnSpc>
             </a:pPr>
             <a:r>
-              <a:rPr sz="1700" b="0" i="0">
-                <a:solidFill>
-                  <a:srgbClr val="202020"/>
-                </a:solidFill>
-                <a:latin typeface="Arial"/>
+              <a:rPr sz="1600" b="0" i="0">
+                <a:solidFill>
+                  <a:srgbClr val="000000"/>
+                </a:solidFill>
+                <a:latin typeface="Georgia"/>
               </a:rPr>
-              <a:t>Presente aqui el contexto y la motivacion del trabajo: el problema abordado, su relevancia dentro de la biologia matematica y los antecedentes mas importantes.</a:t>
-            </a:r>
-          </a:p>
-        </p:txBody>
-      </p:sp>
-      <p:sp>
-        <p:nvSpPr>
-          <p:cNvPr id="11" name="TextBox 10"/>
+              <a:t>Describa el enfoque, modelo matemático, datos y/o algoritmos utilizados.</a:t>
+            </a:r>
+          </a:p>
+        </p:txBody>
+      </p:sp>
+      <p:sp>
+        <p:nvSpPr>
+          <p:cNvPr id="19" name="TextBox 18"/>
           <p:cNvSpPr txBox="1"/>
           <p:nvPr/>
         </p:nvSpPr>
         <p:spPr>
           <a:xfrm>
-            <a:off x="1260000" y="9720000"/>
-            <a:ext cx="13068000" cy="3060000"/>
+            <a:off x="1044000" y="24660000"/>
+            <a:ext cx="13140000" cy="1620000"/>
           </a:xfrm>
           <a:prstGeom prst="rect">
             <a:avLst/>
@@ -3496,90 +3941,233 @@
           </a:bodyPr>
           <a:lstStyle/>
           <a:p>
-            <a:pPr algn="l" marL="228600" indent="-228600">
+            <a:pPr algn="l">
+              <a:lnSpc>
+                <a:spcPct val="115000"/>
+              </a:lnSpc>
+            </a:pPr>
+            <a:r>
+              <a:rPr sz="1600" b="0" i="0">
+                <a:solidFill>
+                  <a:srgbClr val="000000"/>
+                </a:solidFill>
+                <a:latin typeface="Georgia"/>
+              </a:rPr>
+              <a:t>Sed ut perspiciatis unde omnis iste natus error sit voluptatem accusantium doloremque laudantium. Totam rem aperiam, eaque ipsa quae ab illo inventore veritatis et quasi architecto beatae vitae dicta sunt explicabo.</a:t>
+            </a:r>
+          </a:p>
+        </p:txBody>
+      </p:sp>
+      <p:sp>
+        <p:nvSpPr>
+          <p:cNvPr id="20" name="TextBox 19"/>
+          <p:cNvSpPr txBox="1"/>
+          <p:nvPr/>
+        </p:nvSpPr>
+        <p:spPr>
+          <a:xfrm>
+            <a:off x="1044000" y="26388000"/>
+            <a:ext cx="13140000" cy="2160000"/>
+          </a:xfrm>
+          <a:prstGeom prst="rect">
+            <a:avLst/>
+          </a:prstGeom>
+          <a:noFill/>
+        </p:spPr>
+        <p:txBody>
+          <a:bodyPr wrap="square">
+            <a:spAutoFit/>
+          </a:bodyPr>
+          <a:lstStyle/>
+          <a:p>
+            <a:pPr algn="l" marL="285750" indent="-285750">
               <a:lnSpc>
                 <a:spcPct val="115000"/>
               </a:lnSpc>
               <a:spcAft>
                 <a:spcPts val="800"/>
               </a:spcAft>
-              <a:buFont typeface="Arial"/>
-              <a:buChar char="▪"/>
+              <a:buClr>
+                <a:srgbClr val="F19651"/>
+              </a:buClr>
+              <a:buFont typeface="Georgia"/>
+              <a:buChar char="•"/>
             </a:pPr>
             <a:r>
-              <a:rPr sz="1700">
-                <a:solidFill>
-                  <a:srgbClr val="202020"/>
-                </a:solidFill>
-                <a:latin typeface="Arial"/>
+              <a:rPr sz="1600">
+                <a:solidFill>
+                  <a:srgbClr val="000000"/>
+                </a:solidFill>
+                <a:latin typeface="Georgia"/>
               </a:rPr>
-              <a:t>Antecedente o dato relevante 1.</a:t>
-            </a:r>
-          </a:p>
-          <a:p>
-            <a:pPr algn="l" marL="228600" indent="-228600">
+              <a:t>Diseño del estudio / modelo propuesto.</a:t>
+            </a:r>
+          </a:p>
+          <a:p>
+            <a:pPr algn="l" marL="285750" indent="-285750">
               <a:lnSpc>
                 <a:spcPct val="115000"/>
               </a:lnSpc>
               <a:spcAft>
                 <a:spcPts val="800"/>
               </a:spcAft>
-              <a:buFont typeface="Arial"/>
-              <a:buChar char="▪"/>
+              <a:buClr>
+                <a:srgbClr val="F19651"/>
+              </a:buClr>
+              <a:buFont typeface="Georgia"/>
+              <a:buChar char="•"/>
             </a:pPr>
             <a:r>
-              <a:rPr sz="1700">
-                <a:solidFill>
-                  <a:srgbClr val="202020"/>
-                </a:solidFill>
-                <a:latin typeface="Arial"/>
+              <a:rPr sz="1600">
+                <a:solidFill>
+                  <a:srgbClr val="000000"/>
+                </a:solidFill>
+                <a:latin typeface="Georgia"/>
               </a:rPr>
-              <a:t>Antecedente o dato relevante 2.</a:t>
-            </a:r>
-          </a:p>
-          <a:p>
-            <a:pPr algn="l" marL="228600" indent="-228600">
+              <a:t>Fuentes de datos o parámetros.</a:t>
+            </a:r>
+          </a:p>
+          <a:p>
+            <a:pPr algn="l" marL="285750" indent="-285750">
               <a:lnSpc>
                 <a:spcPct val="115000"/>
               </a:lnSpc>
               <a:spcAft>
                 <a:spcPts val="800"/>
               </a:spcAft>
-              <a:buFont typeface="Arial"/>
-              <a:buChar char="▪"/>
+              <a:buClr>
+                <a:srgbClr val="F19651"/>
+              </a:buClr>
+              <a:buFont typeface="Georgia"/>
+              <a:buChar char="•"/>
             </a:pPr>
             <a:r>
-              <a:rPr sz="1700">
-                <a:solidFill>
-                  <a:srgbClr val="202020"/>
-                </a:solidFill>
-                <a:latin typeface="Arial"/>
+              <a:rPr sz="1600">
+                <a:solidFill>
+                  <a:srgbClr val="000000"/>
+                </a:solidFill>
+                <a:latin typeface="Georgia"/>
               </a:rPr>
-              <a:t>Vacio de conocimiento que motiva este trabajo.</a:t>
-            </a:r>
-          </a:p>
-        </p:txBody>
-      </p:sp>
-      <p:sp>
-        <p:nvSpPr>
-          <p:cNvPr id="12" name="Rectangle 11"/>
+              <a:t>Herramientas y métodos de análisis.</a:t>
+            </a:r>
+          </a:p>
+          <a:p>
+            <a:pPr algn="l" marL="285750" indent="-285750">
+              <a:lnSpc>
+                <a:spcPct val="115000"/>
+              </a:lnSpc>
+              <a:spcAft>
+                <a:spcPts val="800"/>
+              </a:spcAft>
+              <a:buClr>
+                <a:srgbClr val="F19651"/>
+              </a:buClr>
+              <a:buFont typeface="Georgia"/>
+              <a:buChar char="•"/>
+            </a:pPr>
+            <a:r>
+              <a:rPr sz="1600">
+                <a:solidFill>
+                  <a:srgbClr val="000000"/>
+                </a:solidFill>
+                <a:latin typeface="Georgia"/>
+              </a:rPr>
+              <a:t>Nemo enim ipsam voluptatem quia voluptas sit aspernatur aut odit aut fugit.</a:t>
+            </a:r>
+          </a:p>
+        </p:txBody>
+      </p:sp>
+      <p:pic>
+        <p:nvPicPr>
+          <p:cNvPr id="21" name="Picture 20" descr="equation_sir.png"/>
+          <p:cNvPicPr>
+            <a:picLocks noChangeAspect="1"/>
+          </p:cNvPicPr>
+          <p:nvPr/>
+        </p:nvPicPr>
+        <p:blipFill>
+          <a:blip r:embed="rId4"/>
+          <a:stretch>
+            <a:fillRect/>
+          </a:stretch>
+        </p:blipFill>
+        <p:spPr>
+          <a:xfrm>
+            <a:off x="3474000" y="28620000"/>
+            <a:ext cx="8280000" cy="3000122"/>
+          </a:xfrm>
+          <a:prstGeom prst="rect">
+            <a:avLst/>
+          </a:prstGeom>
+        </p:spPr>
+      </p:pic>
+      <p:sp>
+        <p:nvSpPr>
+          <p:cNvPr id="22" name="TextBox 21"/>
+          <p:cNvSpPr txBox="1"/>
+          <p:nvPr/>
+        </p:nvSpPr>
+        <p:spPr>
+          <a:xfrm>
+            <a:off x="1044000" y="31764122"/>
+            <a:ext cx="13140000" cy="504000"/>
+          </a:xfrm>
+          <a:prstGeom prst="rect">
+            <a:avLst/>
+          </a:prstGeom>
+          <a:noFill/>
+        </p:spPr>
+        <p:txBody>
+          <a:bodyPr wrap="square">
+            <a:spAutoFit/>
+          </a:bodyPr>
+          <a:lstStyle/>
+          <a:p>
+            <a:pPr algn="ctr"/>
+            <a:r>
+              <a:rPr b="1" sz="1500">
+                <a:solidFill>
+                  <a:srgbClr val="F19651"/>
+                </a:solidFill>
+                <a:latin typeface="Georgia"/>
+              </a:rPr>
+              <a:t>Ejemplo: </a:t>
+            </a:r>
+            <a:r>
+              <a:rPr b="1" sz="1500">
+                <a:solidFill>
+                  <a:srgbClr val="000000"/>
+                </a:solidFill>
+                <a:latin typeface="Georgia"/>
+              </a:rPr>
+              <a:t>modelo SIR de dinámica epidémica</a:t>
+            </a:r>
+          </a:p>
+        </p:txBody>
+      </p:sp>
+      <p:sp>
+        <p:nvSpPr>
+          <p:cNvPr id="23" name="Round Diagonal Corner Rectangle 22"/>
           <p:cNvSpPr/>
           <p:nvPr/>
         </p:nvSpPr>
         <p:spPr>
           <a:xfrm>
-            <a:off x="900000" y="13788000"/>
-            <a:ext cx="13788000" cy="3960000"/>
-          </a:xfrm>
-          <a:prstGeom prst="rect">
-            <a:avLst/>
+            <a:off x="15588000" y="8820000"/>
+            <a:ext cx="14148000" cy="15120000"/>
+          </a:xfrm>
+          <a:prstGeom prst="round2DiagRect">
+            <a:avLst>
+              <a:gd name="adj1" fmla="val 1781"/>
+              <a:gd name="adj2" fmla="val 1781"/>
+            </a:avLst>
           </a:prstGeom>
           <a:solidFill>
             <a:srgbClr val="FFFFFF"/>
           </a:solidFill>
           <a:ln w="25400">
             <a:solidFill>
-              <a:srgbClr val="003B49"/>
+              <a:srgbClr val="F7C59F"/>
             </a:solidFill>
           </a:ln>
           <a:effectLst/>
@@ -3608,25 +4196,146 @@
       </p:sp>
       <p:sp>
         <p:nvSpPr>
-          <p:cNvPr id="13" name="Rectangle 12"/>
-          <p:cNvSpPr/>
+          <p:cNvPr id="24" name="TextBox 23"/>
+          <p:cNvSpPr txBox="1"/>
           <p:nvPr/>
         </p:nvSpPr>
         <p:spPr>
           <a:xfrm>
-            <a:off x="900000" y="13788000"/>
-            <a:ext cx="13788000" cy="720000"/>
+            <a:off x="16092000" y="9324000"/>
+            <a:ext cx="13140000" cy="720000"/>
           </a:xfrm>
           <a:prstGeom prst="rect">
             <a:avLst/>
           </a:prstGeom>
+          <a:noFill/>
+        </p:spPr>
+        <p:txBody>
+          <a:bodyPr wrap="square">
+            <a:spAutoFit/>
+          </a:bodyPr>
+          <a:lstStyle/>
+          <a:p>
+            <a:pPr algn="l">
+              <a:lnSpc>
+                <a:spcPct val="115000"/>
+              </a:lnSpc>
+            </a:pPr>
+            <a:r>
+              <a:rPr sz="2800" b="1" i="0">
+                <a:solidFill>
+                  <a:srgbClr val="1C6EA8"/>
+                </a:solidFill>
+                <a:latin typeface="Arial"/>
+              </a:rPr>
+              <a:t>Resultados</a:t>
+            </a:r>
+          </a:p>
+        </p:txBody>
+      </p:sp>
+      <p:sp>
+        <p:nvSpPr>
+          <p:cNvPr id="25" name="TextBox 24"/>
+          <p:cNvSpPr txBox="1"/>
+          <p:nvPr/>
+        </p:nvSpPr>
+        <p:spPr>
+          <a:xfrm>
+            <a:off x="16092000" y="10260000"/>
+            <a:ext cx="13140000" cy="1080000"/>
+          </a:xfrm>
+          <a:prstGeom prst="rect">
+            <a:avLst/>
+          </a:prstGeom>
+          <a:noFill/>
+        </p:spPr>
+        <p:txBody>
+          <a:bodyPr wrap="square">
+            <a:spAutoFit/>
+          </a:bodyPr>
+          <a:lstStyle/>
+          <a:p>
+            <a:pPr algn="l">
+              <a:lnSpc>
+                <a:spcPct val="115000"/>
+              </a:lnSpc>
+            </a:pPr>
+            <a:r>
+              <a:rPr sz="1600" b="0" i="0">
+                <a:solidFill>
+                  <a:srgbClr val="000000"/>
+                </a:solidFill>
+                <a:latin typeface="Georgia"/>
+              </a:rPr>
+              <a:t>Presente los resultados principales, apoyados en figuras y/o tablas.</a:t>
+            </a:r>
+          </a:p>
+        </p:txBody>
+      </p:sp>
+      <p:sp>
+        <p:nvSpPr>
+          <p:cNvPr id="26" name="TextBox 25"/>
+          <p:cNvSpPr txBox="1"/>
+          <p:nvPr/>
+        </p:nvSpPr>
+        <p:spPr>
+          <a:xfrm>
+            <a:off x="16092000" y="11412000"/>
+            <a:ext cx="13140000" cy="1620000"/>
+          </a:xfrm>
+          <a:prstGeom prst="rect">
+            <a:avLst/>
+          </a:prstGeom>
+          <a:noFill/>
+        </p:spPr>
+        <p:txBody>
+          <a:bodyPr wrap="square">
+            <a:spAutoFit/>
+          </a:bodyPr>
+          <a:lstStyle/>
+          <a:p>
+            <a:pPr algn="l">
+              <a:lnSpc>
+                <a:spcPct val="115000"/>
+              </a:lnSpc>
+            </a:pPr>
+            <a:r>
+              <a:rPr sz="1600" b="0" i="0">
+                <a:solidFill>
+                  <a:srgbClr val="000000"/>
+                </a:solidFill>
+                <a:latin typeface="Georgia"/>
+              </a:rPr>
+              <a:t>Totam rem aperiam, eaque ipsa quae ab illo inventore veritatis et quasi architecto beatae vitae dicta sunt explicabo. Nemo enim ipsam voluptatem quia voluptas sit aspernatur aut odit aut fugit.</a:t>
+            </a:r>
+          </a:p>
+        </p:txBody>
+      </p:sp>
+      <p:sp>
+        <p:nvSpPr>
+          <p:cNvPr id="27" name="Round Diagonal Corner Rectangle 26"/>
+          <p:cNvSpPr/>
+          <p:nvPr/>
+        </p:nvSpPr>
+        <p:spPr>
+          <a:xfrm>
+            <a:off x="16092000" y="13212000"/>
+            <a:ext cx="13140000" cy="5400000"/>
+          </a:xfrm>
+          <a:prstGeom prst="round2DiagRect">
+            <a:avLst>
+              <a:gd name="adj1" fmla="val 4666"/>
+              <a:gd name="adj2" fmla="val 4666"/>
+            </a:avLst>
+          </a:prstGeom>
           <a:solidFill>
-            <a:srgbClr val="003B49"/>
+            <a:srgbClr val="F4F8FB"/>
           </a:solidFill>
-          <a:ln w="25400">
+          <a:ln w="15875">
             <a:solidFill>
-              <a:srgbClr val="003B49"/>
+              <a:srgbClr val="1C6EA8"/>
             </a:solidFill>
+            <a:prstDash val="dash"/>
           </a:ln>
           <a:effectLst/>
         </p:spPr>
@@ -3645,23 +4354,33 @@
           </a:fontRef>
         </p:style>
         <p:txBody>
-          <a:bodyPr rtlCol="0" anchor="ctr"/>
+          <a:bodyPr rtlCol="0" anchor="ctr" wrap="square"/>
           <a:lstStyle/>
           <a:p>
             <a:pPr algn="ctr"/>
-          </a:p>
-        </p:txBody>
-      </p:sp>
-      <p:sp>
-        <p:nvSpPr>
-          <p:cNvPr id="14" name="TextBox 13"/>
+            <a:r>
+              <a:rPr sz="1600">
+                <a:solidFill>
+                  <a:srgbClr val="1C6EA8"/>
+                </a:solidFill>
+                <a:latin typeface="Georgia"/>
+              </a:rPr>
+              <a:t>Espacio para figura principal
+(gráfico, mapa, simulación, etc.)</a:t>
+            </a:r>
+          </a:p>
+        </p:txBody>
+      </p:sp>
+      <p:sp>
+        <p:nvSpPr>
+          <p:cNvPr id="28" name="TextBox 27"/>
           <p:cNvSpPr txBox="1"/>
           <p:nvPr/>
         </p:nvSpPr>
         <p:spPr>
           <a:xfrm>
-            <a:off x="1260000" y="13788000"/>
-            <a:ext cx="13068000" cy="720000"/>
+            <a:off x="16092000" y="18756000"/>
+            <a:ext cx="13140000" cy="504000"/>
           </a:xfrm>
           <a:prstGeom prst="rect">
             <a:avLst/>
@@ -3669,38 +4388,43 @@
           <a:noFill/>
         </p:spPr>
         <p:txBody>
-          <a:bodyPr wrap="square" anchor="ctr">
+          <a:bodyPr wrap="square">
             <a:spAutoFit/>
           </a:bodyPr>
           <a:lstStyle/>
           <a:p>
-            <a:pPr algn="l">
-              <a:lnSpc>
-                <a:spcPct val="115000"/>
-              </a:lnSpc>
-            </a:pPr>
-            <a:r>
-              <a:rPr sz="2600" b="1" i="0">
-                <a:solidFill>
-                  <a:srgbClr val="FFFFFF"/>
+            <a:pPr algn="ctr"/>
+            <a:r>
+              <a:rPr b="1" sz="1500">
+                <a:solidFill>
+                  <a:srgbClr val="F19651"/>
                 </a:solidFill>
                 <a:latin typeface="Georgia"/>
               </a:rPr>
-              <a:t>Objetivos</a:t>
-            </a:r>
-          </a:p>
-        </p:txBody>
-      </p:sp>
-      <p:sp>
-        <p:nvSpPr>
-          <p:cNvPr id="15" name="TextBox 14"/>
+              <a:t>Figura: </a:t>
+            </a:r>
+            <a:r>
+              <a:rPr b="1" sz="1500">
+                <a:solidFill>
+                  <a:srgbClr val="000000"/>
+                </a:solidFill>
+                <a:latin typeface="Georgia"/>
+              </a:rPr>
+              <a:t>Descripción breve del resultado.</a:t>
+            </a:r>
+          </a:p>
+        </p:txBody>
+      </p:sp>
+      <p:sp>
+        <p:nvSpPr>
+          <p:cNvPr id="29" name="TextBox 28"/>
           <p:cNvSpPr txBox="1"/>
           <p:nvPr/>
         </p:nvSpPr>
         <p:spPr>
           <a:xfrm>
-            <a:off x="1260000" y="14868000"/>
-            <a:ext cx="13068000" cy="2520000"/>
+            <a:off x="16092000" y="19476000"/>
+            <a:ext cx="13140000" cy="504000"/>
           </a:xfrm>
           <a:prstGeom prst="rect">
             <a:avLst/>
@@ -3713,90 +4437,502 @@
           </a:bodyPr>
           <a:lstStyle/>
           <a:p>
-            <a:pPr algn="l" marL="228600" indent="-228600">
+            <a:pPr algn="ctr"/>
+            <a:r>
+              <a:rPr b="1" sz="1500">
+                <a:solidFill>
+                  <a:srgbClr val="F19651"/>
+                </a:solidFill>
+                <a:latin typeface="Georgia"/>
+              </a:rPr>
+              <a:t>Tabla: </a:t>
+            </a:r>
+            <a:r>
+              <a:rPr b="1" sz="1500">
+                <a:solidFill>
+                  <a:srgbClr val="000000"/>
+                </a:solidFill>
+                <a:latin typeface="Georgia"/>
+              </a:rPr>
+              <a:t>Descripción breve de la tabla.</a:t>
+            </a:r>
+          </a:p>
+        </p:txBody>
+      </p:sp>
+      <p:graphicFrame>
+        <p:nvGraphicFramePr>
+          <p:cNvPr id="30" name="Table 29"/>
+          <p:cNvGraphicFramePr>
+            <a:graphicFrameLocks noGrp="1"/>
+          </p:cNvGraphicFramePr>
+          <p:nvPr/>
+        </p:nvGraphicFramePr>
+        <p:xfrm>
+          <a:off x="16092000" y="20052000"/>
+          <a:ext cx="13140000" cy="2016000"/>
+        </p:xfrm>
+        <a:graphic>
+          <a:graphicData uri="http://schemas.openxmlformats.org/drawingml/2006/table">
+            <a:tbl>
+              <a:tblPr firstRow="1" bandRow="1">
+                <a:tableStyleId>{5C22544A-7EE6-4342-B048-85BDC9FD1C3A}</a:tableStyleId>
+              </a:tblPr>
+              <a:tblGrid>
+                <a:gridCol w="3285000"/>
+                <a:gridCol w="3285000"/>
+                <a:gridCol w="3285000"/>
+                <a:gridCol w="3285000"/>
+              </a:tblGrid>
+              <a:tr h="504000">
+                <a:tc>
+                  <a:txBody>
+                    <a:bodyPr/>
+                    <a:lstStyle/>
+                    <a:p>
+                      <a:pPr algn="l"/>
+                      <a:r>
+                        <a:rPr sz="1400" b="1">
+                          <a:latin typeface="Georgia"/>
+                        </a:rPr>
+                        <a:t>Parámetro</a:t>
+                      </a:r>
+                    </a:p>
+                  </a:txBody>
+                  <a:tcPr anchor="ctr" marL="108000" marR="108000" marT="36000" marB="36000">
+                    <a:solidFill>
+                      <a:srgbClr val="EDF3F8"/>
+                    </a:solidFill>
+                  </a:tcPr>
+                </a:tc>
+                <a:tc>
+                  <a:txBody>
+                    <a:bodyPr/>
+                    <a:lstStyle/>
+                    <a:p>
+                      <a:pPr algn="ctr"/>
+                      <a:r>
+                        <a:rPr sz="1400" b="1">
+                          <a:latin typeface="Georgia"/>
+                        </a:rPr>
+                        <a:t>Valor</a:t>
+                      </a:r>
+                    </a:p>
+                  </a:txBody>
+                  <a:tcPr anchor="ctr" marL="108000" marR="108000" marT="36000" marB="36000">
+                    <a:solidFill>
+                      <a:srgbClr val="EDF3F8"/>
+                    </a:solidFill>
+                  </a:tcPr>
+                </a:tc>
+                <a:tc>
+                  <a:txBody>
+                    <a:bodyPr/>
+                    <a:lstStyle/>
+                    <a:p>
+                      <a:pPr algn="ctr"/>
+                      <a:r>
+                        <a:rPr sz="1400" b="1">
+                          <a:latin typeface="Georgia"/>
+                        </a:rPr>
+                        <a:t>IC 95%</a:t>
+                      </a:r>
+                    </a:p>
+                  </a:txBody>
+                  <a:tcPr anchor="ctr" marL="108000" marR="108000" marT="36000" marB="36000">
+                    <a:solidFill>
+                      <a:srgbClr val="EDF3F8"/>
+                    </a:solidFill>
+                  </a:tcPr>
+                </a:tc>
+                <a:tc>
+                  <a:txBody>
+                    <a:bodyPr/>
+                    <a:lstStyle/>
+                    <a:p>
+                      <a:pPr algn="ctr"/>
+                      <a:r>
+                        <a:rPr sz="1400" b="1">
+                          <a:latin typeface="Georgia"/>
+                        </a:rPr>
+                        <a:t>p</a:t>
+                      </a:r>
+                    </a:p>
+                  </a:txBody>
+                  <a:tcPr anchor="ctr" marL="108000" marR="108000" marT="36000" marB="36000">
+                    <a:solidFill>
+                      <a:srgbClr val="EDF3F8"/>
+                    </a:solidFill>
+                  </a:tcPr>
+                </a:tc>
+              </a:tr>
+              <a:tr h="504000">
+                <a:tc>
+                  <a:txBody>
+                    <a:bodyPr/>
+                    <a:lstStyle/>
+                    <a:p>
+                      <a:pPr algn="l"/>
+                      <a:r>
+                        <a:rPr sz="1400" b="0">
+                          <a:latin typeface="Georgia"/>
+                        </a:rPr>
+                        <a:t>Parámetro 1</a:t>
+                      </a:r>
+                    </a:p>
+                  </a:txBody>
+                  <a:tcPr anchor="ctr" marL="108000" marR="108000" marT="36000" marB="36000">
+                    <a:solidFill>
+                      <a:srgbClr val="FFFFFF"/>
+                    </a:solidFill>
+                  </a:tcPr>
+                </a:tc>
+                <a:tc>
+                  <a:txBody>
+                    <a:bodyPr/>
+                    <a:lstStyle/>
+                    <a:p>
+                      <a:pPr algn="ctr"/>
+                      <a:r>
+                        <a:rPr sz="1400" b="0">
+                          <a:latin typeface="Georgia"/>
+                        </a:rPr>
+                        <a:t>3.14</a:t>
+                      </a:r>
+                    </a:p>
+                  </a:txBody>
+                  <a:tcPr anchor="ctr" marL="108000" marR="108000" marT="36000" marB="36000">
+                    <a:solidFill>
+                      <a:srgbClr val="FFFFFF"/>
+                    </a:solidFill>
+                  </a:tcPr>
+                </a:tc>
+                <a:tc>
+                  <a:txBody>
+                    <a:bodyPr/>
+                    <a:lstStyle/>
+                    <a:p>
+                      <a:pPr algn="ctr"/>
+                      <a:r>
+                        <a:rPr sz="1400" b="0">
+                          <a:latin typeface="Georgia"/>
+                        </a:rPr>
+                        <a:t>(3.10, 3.18)</a:t>
+                      </a:r>
+                    </a:p>
+                  </a:txBody>
+                  <a:tcPr anchor="ctr" marL="108000" marR="108000" marT="36000" marB="36000">
+                    <a:solidFill>
+                      <a:srgbClr val="FFFFFF"/>
+                    </a:solidFill>
+                  </a:tcPr>
+                </a:tc>
+                <a:tc>
+                  <a:txBody>
+                    <a:bodyPr/>
+                    <a:lstStyle/>
+                    <a:p>
+                      <a:pPr algn="ctr"/>
+                      <a:r>
+                        <a:rPr sz="1400" b="0">
+                          <a:latin typeface="Georgia"/>
+                        </a:rPr>
+                        <a:t>0.001</a:t>
+                      </a:r>
+                    </a:p>
+                  </a:txBody>
+                  <a:tcPr anchor="ctr" marL="108000" marR="108000" marT="36000" marB="36000">
+                    <a:solidFill>
+                      <a:srgbClr val="FFFFFF"/>
+                    </a:solidFill>
+                  </a:tcPr>
+                </a:tc>
+              </a:tr>
+              <a:tr h="504000">
+                <a:tc>
+                  <a:txBody>
+                    <a:bodyPr/>
+                    <a:lstStyle/>
+                    <a:p>
+                      <a:pPr algn="l"/>
+                      <a:r>
+                        <a:rPr sz="1400" b="0">
+                          <a:latin typeface="Georgia"/>
+                        </a:rPr>
+                        <a:t>Parámetro 2</a:t>
+                      </a:r>
+                    </a:p>
+                  </a:txBody>
+                  <a:tcPr anchor="ctr" marL="108000" marR="108000" marT="36000" marB="36000">
+                    <a:solidFill>
+                      <a:srgbClr val="FFFFFF"/>
+                    </a:solidFill>
+                  </a:tcPr>
+                </a:tc>
+                <a:tc>
+                  <a:txBody>
+                    <a:bodyPr/>
+                    <a:lstStyle/>
+                    <a:p>
+                      <a:pPr algn="ctr"/>
+                      <a:r>
+                        <a:rPr sz="1400" b="0">
+                          <a:latin typeface="Georgia"/>
+                        </a:rPr>
+                        <a:t>2.72</a:t>
+                      </a:r>
+                    </a:p>
+                  </a:txBody>
+                  <a:tcPr anchor="ctr" marL="108000" marR="108000" marT="36000" marB="36000">
+                    <a:solidFill>
+                      <a:srgbClr val="FFFFFF"/>
+                    </a:solidFill>
+                  </a:tcPr>
+                </a:tc>
+                <a:tc>
+                  <a:txBody>
+                    <a:bodyPr/>
+                    <a:lstStyle/>
+                    <a:p>
+                      <a:pPr algn="ctr"/>
+                      <a:r>
+                        <a:rPr sz="1400" b="0">
+                          <a:latin typeface="Georgia"/>
+                        </a:rPr>
+                        <a:t>(2.68, 2.76)</a:t>
+                      </a:r>
+                    </a:p>
+                  </a:txBody>
+                  <a:tcPr anchor="ctr" marL="108000" marR="108000" marT="36000" marB="36000">
+                    <a:solidFill>
+                      <a:srgbClr val="FFFFFF"/>
+                    </a:solidFill>
+                  </a:tcPr>
+                </a:tc>
+                <a:tc>
+                  <a:txBody>
+                    <a:bodyPr/>
+                    <a:lstStyle/>
+                    <a:p>
+                      <a:pPr algn="ctr"/>
+                      <a:r>
+                        <a:rPr sz="1400" b="0">
+                          <a:latin typeface="Georgia"/>
+                        </a:rPr>
+                        <a:t>0.007</a:t>
+                      </a:r>
+                    </a:p>
+                  </a:txBody>
+                  <a:tcPr anchor="ctr" marL="108000" marR="108000" marT="36000" marB="36000">
+                    <a:solidFill>
+                      <a:srgbClr val="FFFFFF"/>
+                    </a:solidFill>
+                  </a:tcPr>
+                </a:tc>
+              </a:tr>
+              <a:tr h="504000">
+                <a:tc>
+                  <a:txBody>
+                    <a:bodyPr/>
+                    <a:lstStyle/>
+                    <a:p>
+                      <a:pPr algn="l"/>
+                      <a:r>
+                        <a:rPr sz="1400" b="0">
+                          <a:latin typeface="Georgia"/>
+                        </a:rPr>
+                        <a:t>Parámetro 3</a:t>
+                      </a:r>
+                    </a:p>
+                  </a:txBody>
+                  <a:tcPr anchor="ctr" marL="108000" marR="108000" marT="36000" marB="36000">
+                    <a:solidFill>
+                      <a:srgbClr val="FFFFFF"/>
+                    </a:solidFill>
+                  </a:tcPr>
+                </a:tc>
+                <a:tc>
+                  <a:txBody>
+                    <a:bodyPr/>
+                    <a:lstStyle/>
+                    <a:p>
+                      <a:pPr algn="ctr"/>
+                      <a:r>
+                        <a:rPr sz="1400" b="0">
+                          <a:latin typeface="Georgia"/>
+                        </a:rPr>
+                        <a:t>1.62</a:t>
+                      </a:r>
+                    </a:p>
+                  </a:txBody>
+                  <a:tcPr anchor="ctr" marL="108000" marR="108000" marT="36000" marB="36000">
+                    <a:solidFill>
+                      <a:srgbClr val="FFFFFF"/>
+                    </a:solidFill>
+                  </a:tcPr>
+                </a:tc>
+                <a:tc>
+                  <a:txBody>
+                    <a:bodyPr/>
+                    <a:lstStyle/>
+                    <a:p>
+                      <a:pPr algn="ctr"/>
+                      <a:r>
+                        <a:rPr sz="1400" b="0">
+                          <a:latin typeface="Georgia"/>
+                        </a:rPr>
+                        <a:t>(1.58, 1.66)</a:t>
+                      </a:r>
+                    </a:p>
+                  </a:txBody>
+                  <a:tcPr anchor="ctr" marL="108000" marR="108000" marT="36000" marB="36000">
+                    <a:solidFill>
+                      <a:srgbClr val="FFFFFF"/>
+                    </a:solidFill>
+                  </a:tcPr>
+                </a:tc>
+                <a:tc>
+                  <a:txBody>
+                    <a:bodyPr/>
+                    <a:lstStyle/>
+                    <a:p>
+                      <a:pPr algn="ctr"/>
+                      <a:r>
+                        <a:rPr sz="1400" b="0">
+                          <a:latin typeface="Georgia"/>
+                        </a:rPr>
+                        <a:t>0.042</a:t>
+                      </a:r>
+                    </a:p>
+                  </a:txBody>
+                  <a:tcPr anchor="ctr" marL="108000" marR="108000" marT="36000" marB="36000">
+                    <a:solidFill>
+                      <a:srgbClr val="FFFFFF"/>
+                    </a:solidFill>
+                  </a:tcPr>
+                </a:tc>
+              </a:tr>
+            </a:tbl>
+          </a:graphicData>
+        </a:graphic>
+      </p:graphicFrame>
+      <p:sp>
+        <p:nvSpPr>
+          <p:cNvPr id="31" name="TextBox 30"/>
+          <p:cNvSpPr txBox="1"/>
+          <p:nvPr/>
+        </p:nvSpPr>
+        <p:spPr>
+          <a:xfrm>
+            <a:off x="16092000" y="22428000"/>
+            <a:ext cx="13140000" cy="1008000"/>
+          </a:xfrm>
+          <a:prstGeom prst="rect">
+            <a:avLst/>
+          </a:prstGeom>
+          <a:noFill/>
+        </p:spPr>
+        <p:txBody>
+          <a:bodyPr wrap="square">
+            <a:spAutoFit/>
+          </a:bodyPr>
+          <a:lstStyle/>
+          <a:p>
+            <a:pPr algn="l" marL="285750" indent="-285750">
               <a:lnSpc>
                 <a:spcPct val="115000"/>
               </a:lnSpc>
               <a:spcAft>
                 <a:spcPts val="800"/>
               </a:spcAft>
-              <a:buFont typeface="Arial"/>
-              <a:buChar char="▪"/>
+              <a:buClr>
+                <a:srgbClr val="F19651"/>
+              </a:buClr>
+              <a:buFont typeface="Georgia"/>
+              <a:buChar char="•"/>
             </a:pPr>
             <a:r>
-              <a:rPr sz="1700">
-                <a:solidFill>
-                  <a:srgbClr val="202020"/>
-                </a:solidFill>
-                <a:latin typeface="Arial"/>
+              <a:rPr sz="1600">
+                <a:solidFill>
+                  <a:srgbClr val="000000"/>
+                </a:solidFill>
+                <a:latin typeface="Georgia"/>
               </a:rPr>
-              <a:t>Objetivo general del trabajo.</a:t>
-            </a:r>
-          </a:p>
-          <a:p>
-            <a:pPr algn="l" marL="228600" indent="-228600">
+              <a:t>Sed ut perspiciatis unde omnis iste natus error sit voluptatem accusantium doloremque laudantium.</a:t>
+            </a:r>
+          </a:p>
+          <a:p>
+            <a:pPr algn="l" marL="285750" indent="-285750">
               <a:lnSpc>
                 <a:spcPct val="115000"/>
               </a:lnSpc>
               <a:spcAft>
                 <a:spcPts val="800"/>
               </a:spcAft>
-              <a:buFont typeface="Arial"/>
-              <a:buChar char="▪"/>
+              <a:buClr>
+                <a:srgbClr val="F19651"/>
+              </a:buClr>
+              <a:buFont typeface="Georgia"/>
+              <a:buChar char="•"/>
             </a:pPr>
             <a:r>
-              <a:rPr sz="1700">
-                <a:solidFill>
-                  <a:srgbClr val="202020"/>
-                </a:solidFill>
-                <a:latin typeface="Arial"/>
+              <a:rPr sz="1600">
+                <a:solidFill>
+                  <a:srgbClr val="000000"/>
+                </a:solidFill>
+                <a:latin typeface="Georgia"/>
               </a:rPr>
-              <a:t>Objetivo especifico 1.</a:t>
-            </a:r>
-          </a:p>
-          <a:p>
-            <a:pPr algn="l" marL="228600" indent="-228600">
+              <a:t>Nemo enim ipsam voluptatem quia voluptas sit aspernatur aut odit aut fugit, sed quia consequuntur magni dolores.</a:t>
+            </a:r>
+          </a:p>
+          <a:p>
+            <a:pPr algn="l" marL="285750" indent="-285750">
               <a:lnSpc>
                 <a:spcPct val="115000"/>
               </a:lnSpc>
               <a:spcAft>
                 <a:spcPts val="800"/>
               </a:spcAft>
-              <a:buFont typeface="Arial"/>
-              <a:buChar char="▪"/>
+              <a:buClr>
+                <a:srgbClr val="F19651"/>
+              </a:buClr>
+              <a:buFont typeface="Georgia"/>
+              <a:buChar char="•"/>
             </a:pPr>
             <a:r>
-              <a:rPr sz="1700">
-                <a:solidFill>
-                  <a:srgbClr val="202020"/>
-                </a:solidFill>
-                <a:latin typeface="Arial"/>
+              <a:rPr sz="1600">
+                <a:solidFill>
+                  <a:srgbClr val="000000"/>
+                </a:solidFill>
+                <a:latin typeface="Georgia"/>
               </a:rPr>
-              <a:t>Objetivo especifico 2.</a:t>
-            </a:r>
-          </a:p>
-        </p:txBody>
-      </p:sp>
-      <p:sp>
-        <p:nvSpPr>
-          <p:cNvPr id="16" name="Rectangle 15"/>
+              <a:t>Neque porro quisquam est, qui dolorem ipsum quia dolor sit amet, consectetur, adipisci velit.</a:t>
+            </a:r>
+          </a:p>
+        </p:txBody>
+      </p:sp>
+      <p:sp>
+        <p:nvSpPr>
+          <p:cNvPr id="32" name="Round Diagonal Corner Rectangle 31"/>
           <p:cNvSpPr/>
           <p:nvPr/>
         </p:nvSpPr>
         <p:spPr>
           <a:xfrm>
-            <a:off x="900000" y="18396000"/>
-            <a:ext cx="13788000" cy="9360000"/>
-          </a:xfrm>
-          <a:prstGeom prst="rect">
-            <a:avLst/>
+            <a:off x="15588000" y="24660000"/>
+            <a:ext cx="14148000" cy="3240000"/>
+          </a:xfrm>
+          <a:prstGeom prst="round2DiagRect">
+            <a:avLst>
+              <a:gd name="adj1" fmla="val 7777"/>
+              <a:gd name="adj2" fmla="val 7777"/>
+            </a:avLst>
           </a:prstGeom>
           <a:solidFill>
             <a:srgbClr val="FFFFFF"/>
           </a:solidFill>
           <a:ln w="25400">
             <a:solidFill>
-              <a:srgbClr val="003B49"/>
+              <a:srgbClr val="F7C59F"/>
             </a:solidFill>
           </a:ln>
           <a:effectLst/>
@@ -3825,24 +4961,161 @@
       </p:sp>
       <p:sp>
         <p:nvSpPr>
-          <p:cNvPr id="17" name="Rectangle 16"/>
-          <p:cNvSpPr/>
+          <p:cNvPr id="33" name="TextBox 32"/>
+          <p:cNvSpPr txBox="1"/>
           <p:nvPr/>
         </p:nvSpPr>
         <p:spPr>
           <a:xfrm>
-            <a:off x="900000" y="18396000"/>
-            <a:ext cx="13788000" cy="720000"/>
+            <a:off x="16092000" y="25164000"/>
+            <a:ext cx="13140000" cy="720000"/>
           </a:xfrm>
           <a:prstGeom prst="rect">
             <a:avLst/>
           </a:prstGeom>
+          <a:noFill/>
+        </p:spPr>
+        <p:txBody>
+          <a:bodyPr wrap="square">
+            <a:spAutoFit/>
+          </a:bodyPr>
+          <a:lstStyle/>
+          <a:p>
+            <a:pPr algn="l">
+              <a:lnSpc>
+                <a:spcPct val="115000"/>
+              </a:lnSpc>
+            </a:pPr>
+            <a:r>
+              <a:rPr sz="2800" b="1" i="0">
+                <a:solidFill>
+                  <a:srgbClr val="1C6EA8"/>
+                </a:solidFill>
+                <a:latin typeface="Arial"/>
+              </a:rPr>
+              <a:t>Conclusiones</a:t>
+            </a:r>
+          </a:p>
+        </p:txBody>
+      </p:sp>
+      <p:sp>
+        <p:nvSpPr>
+          <p:cNvPr id="34" name="TextBox 33"/>
+          <p:cNvSpPr txBox="1"/>
+          <p:nvPr/>
+        </p:nvSpPr>
+        <p:spPr>
+          <a:xfrm>
+            <a:off x="16092000" y="26100000"/>
+            <a:ext cx="13140000" cy="1296000"/>
+          </a:xfrm>
+          <a:prstGeom prst="rect">
+            <a:avLst/>
+          </a:prstGeom>
+          <a:noFill/>
+        </p:spPr>
+        <p:txBody>
+          <a:bodyPr wrap="square">
+            <a:spAutoFit/>
+          </a:bodyPr>
+          <a:lstStyle/>
+          <a:p>
+            <a:pPr algn="l" marL="285750" indent="-285750">
+              <a:lnSpc>
+                <a:spcPct val="115000"/>
+              </a:lnSpc>
+              <a:spcAft>
+                <a:spcPts val="800"/>
+              </a:spcAft>
+              <a:buClr>
+                <a:srgbClr val="F19651"/>
+              </a:buClr>
+              <a:buFont typeface="Georgia"/>
+              <a:buChar char="•"/>
+            </a:pPr>
+            <a:r>
+              <a:rPr sz="1600">
+                <a:solidFill>
+                  <a:srgbClr val="000000"/>
+                </a:solidFill>
+                <a:latin typeface="Georgia"/>
+              </a:rPr>
+              <a:t>Conclusión principal 1.</a:t>
+            </a:r>
+          </a:p>
+          <a:p>
+            <a:pPr algn="l" marL="285750" indent="-285750">
+              <a:lnSpc>
+                <a:spcPct val="115000"/>
+              </a:lnSpc>
+              <a:spcAft>
+                <a:spcPts val="800"/>
+              </a:spcAft>
+              <a:buClr>
+                <a:srgbClr val="F19651"/>
+              </a:buClr>
+              <a:buFont typeface="Georgia"/>
+              <a:buChar char="•"/>
+            </a:pPr>
+            <a:r>
+              <a:rPr sz="1600">
+                <a:solidFill>
+                  <a:srgbClr val="000000"/>
+                </a:solidFill>
+                <a:latin typeface="Georgia"/>
+              </a:rPr>
+              <a:t>Conclusión principal 2.</a:t>
+            </a:r>
+          </a:p>
+          <a:p>
+            <a:pPr algn="l" marL="285750" indent="-285750">
+              <a:lnSpc>
+                <a:spcPct val="115000"/>
+              </a:lnSpc>
+              <a:spcAft>
+                <a:spcPts val="800"/>
+              </a:spcAft>
+              <a:buClr>
+                <a:srgbClr val="F19651"/>
+              </a:buClr>
+              <a:buFont typeface="Georgia"/>
+              <a:buChar char="•"/>
+            </a:pPr>
+            <a:r>
+              <a:rPr sz="1600">
+                <a:solidFill>
+                  <a:srgbClr val="000000"/>
+                </a:solidFill>
+                <a:latin typeface="Georgia"/>
+              </a:rPr>
+              <a:t>Proyecciones o trabajo futuro.</a:t>
+            </a:r>
+          </a:p>
+        </p:txBody>
+      </p:sp>
+      <p:sp>
+        <p:nvSpPr>
+          <p:cNvPr id="35" name="Round Diagonal Corner Rectangle 34"/>
+          <p:cNvSpPr/>
+          <p:nvPr/>
+        </p:nvSpPr>
+        <p:spPr>
+          <a:xfrm>
+            <a:off x="15588000" y="28620000"/>
+            <a:ext cx="14148000" cy="4320000"/>
+          </a:xfrm>
+          <a:prstGeom prst="round2DiagRect">
+            <a:avLst>
+              <a:gd name="adj1" fmla="val 5833"/>
+              <a:gd name="adj2" fmla="val 5833"/>
+            </a:avLst>
+          </a:prstGeom>
           <a:solidFill>
-            <a:srgbClr val="003B49"/>
+            <a:srgbClr val="FFFFFF"/>
           </a:solidFill>
           <a:ln w="25400">
             <a:solidFill>
-              <a:srgbClr val="003B49"/>
+              <a:srgbClr val="F7C59F"/>
             </a:solidFill>
           </a:ln>
           <a:effectLst/>
@@ -3871,14 +5144,14 @@
       </p:sp>
       <p:sp>
         <p:nvSpPr>
-          <p:cNvPr id="18" name="TextBox 17"/>
+          <p:cNvPr id="36" name="TextBox 35"/>
           <p:cNvSpPr txBox="1"/>
           <p:nvPr/>
         </p:nvSpPr>
         <p:spPr>
           <a:xfrm>
-            <a:off x="1260000" y="18396000"/>
-            <a:ext cx="13068000" cy="720000"/>
+            <a:off x="16092000" y="29124000"/>
+            <a:ext cx="13140000" cy="720000"/>
           </a:xfrm>
           <a:prstGeom prst="rect">
             <a:avLst/>
@@ -3886,7 +5159,7 @@
           <a:noFill/>
         </p:spPr>
         <p:txBody>
-          <a:bodyPr wrap="square" anchor="ctr">
+          <a:bodyPr wrap="square">
             <a:spAutoFit/>
           </a:bodyPr>
           <a:lstStyle/>
@@ -3897,27 +5170,27 @@
               </a:lnSpc>
             </a:pPr>
             <a:r>
-              <a:rPr sz="2600" b="1" i="0">
-                <a:solidFill>
-                  <a:srgbClr val="FFFFFF"/>
-                </a:solidFill>
-                <a:latin typeface="Georgia"/>
+              <a:rPr sz="2800" b="1" i="0">
+                <a:solidFill>
+                  <a:srgbClr val="1C6EA8"/>
+                </a:solidFill>
+                <a:latin typeface="Arial"/>
               </a:rPr>
-              <a:t>Metodologia</a:t>
-            </a:r>
-          </a:p>
-        </p:txBody>
-      </p:sp>
-      <p:sp>
-        <p:nvSpPr>
-          <p:cNvPr id="19" name="TextBox 18"/>
+              <a:t>Referencias</a:t>
+            </a:r>
+          </a:p>
+        </p:txBody>
+      </p:sp>
+      <p:sp>
+        <p:nvSpPr>
+          <p:cNvPr id="37" name="TextBox 36"/>
           <p:cNvSpPr txBox="1"/>
           <p:nvPr/>
         </p:nvSpPr>
         <p:spPr>
           <a:xfrm>
-            <a:off x="1260000" y="19476000"/>
-            <a:ext cx="13068000" cy="1260000"/>
+            <a:off x="16092000" y="30060000"/>
+            <a:ext cx="13140000" cy="2376000"/>
           </a:xfrm>
           <a:prstGeom prst="rect">
             <a:avLst/>
@@ -3936,123 +5209,105 @@
               </a:lnSpc>
             </a:pPr>
             <a:r>
-              <a:rPr sz="1700" b="0" i="0">
-                <a:solidFill>
-                  <a:srgbClr val="202020"/>
-                </a:solidFill>
-                <a:latin typeface="Arial"/>
+              <a:rPr sz="1300" b="0" i="0">
+                <a:solidFill>
+                  <a:srgbClr val="000000"/>
+                </a:solidFill>
+                <a:latin typeface="Georgia"/>
               </a:rPr>
-              <a:t>Describa el enfoque, modelo matematico, datos y/o algoritmos utilizados.</a:t>
-            </a:r>
-          </a:p>
-        </p:txBody>
-      </p:sp>
-      <p:sp>
-        <p:nvSpPr>
-          <p:cNvPr id="20" name="TextBox 19"/>
-          <p:cNvSpPr txBox="1"/>
-          <p:nvPr/>
-        </p:nvSpPr>
-        <p:spPr>
-          <a:xfrm>
-            <a:off x="1260000" y="20844000"/>
-            <a:ext cx="13068000" cy="2520000"/>
-          </a:xfrm>
-          <a:prstGeom prst="rect">
-            <a:avLst/>
-          </a:prstGeom>
-          <a:noFill/>
-        </p:spPr>
-        <p:txBody>
-          <a:bodyPr wrap="square">
-            <a:spAutoFit/>
-          </a:bodyPr>
-          <a:lstStyle/>
-          <a:p>
-            <a:pPr algn="l" marL="228600" indent="-228600">
+              <a:t>[1] Apellido, N. (Año). Título del artículo. Revista, vol(núm), páginas.</a:t>
+            </a:r>
+          </a:p>
+          <a:p>
+            <a:pPr algn="l">
               <a:lnSpc>
                 <a:spcPct val="115000"/>
               </a:lnSpc>
-              <a:spcAft>
-                <a:spcPts val="800"/>
-              </a:spcAft>
-              <a:buFont typeface="Arial"/>
-              <a:buChar char="▪"/>
             </a:pPr>
             <a:r>
-              <a:rPr sz="1700">
-                <a:solidFill>
-                  <a:srgbClr val="202020"/>
-                </a:solidFill>
-                <a:latin typeface="Arial"/>
+              <a:rPr sz="1300" b="0" i="0">
+                <a:solidFill>
+                  <a:srgbClr val="000000"/>
+                </a:solidFill>
+                <a:latin typeface="Georgia"/>
               </a:rPr>
-              <a:t>Diseno del estudio / modelo propuesto.</a:t>
-            </a:r>
-          </a:p>
-          <a:p>
-            <a:pPr algn="l" marL="228600" indent="-228600">
+              <a:t/>
+            </a:r>
+          </a:p>
+          <a:p>
+            <a:pPr algn="l">
               <a:lnSpc>
                 <a:spcPct val="115000"/>
               </a:lnSpc>
-              <a:spcAft>
-                <a:spcPts val="800"/>
-              </a:spcAft>
-              <a:buFont typeface="Arial"/>
-              <a:buChar char="▪"/>
             </a:pPr>
             <a:r>
-              <a:rPr sz="1700">
-                <a:solidFill>
-                  <a:srgbClr val="202020"/>
-                </a:solidFill>
-                <a:latin typeface="Arial"/>
+              <a:rPr sz="1300" b="0" i="0">
+                <a:solidFill>
+                  <a:srgbClr val="000000"/>
+                </a:solidFill>
+                <a:latin typeface="Georgia"/>
               </a:rPr>
-              <a:t>Fuentes de datos o parametros.</a:t>
-            </a:r>
-          </a:p>
-          <a:p>
-            <a:pPr algn="l" marL="228600" indent="-228600">
+              <a:t>[2] Apellido, N. &amp; Apellido, N. (Año). Título del artículo. Revista, vol(núm), páginas.</a:t>
+            </a:r>
+          </a:p>
+          <a:p>
+            <a:pPr algn="l">
               <a:lnSpc>
                 <a:spcPct val="115000"/>
               </a:lnSpc>
-              <a:spcAft>
-                <a:spcPts val="800"/>
-              </a:spcAft>
-              <a:buFont typeface="Arial"/>
-              <a:buChar char="▪"/>
             </a:pPr>
             <a:r>
-              <a:rPr sz="1700">
-                <a:solidFill>
-                  <a:srgbClr val="202020"/>
-                </a:solidFill>
-                <a:latin typeface="Arial"/>
+              <a:rPr sz="1300" b="0" i="0">
+                <a:solidFill>
+                  <a:srgbClr val="000000"/>
+                </a:solidFill>
+                <a:latin typeface="Georgia"/>
               </a:rPr>
-              <a:t>Herramientas y metodos de analisis.</a:t>
-            </a:r>
-          </a:p>
-        </p:txBody>
-      </p:sp>
-      <p:sp>
-        <p:nvSpPr>
-          <p:cNvPr id="21" name="Rectangle 20"/>
+              <a:t/>
+            </a:r>
+          </a:p>
+          <a:p>
+            <a:pPr algn="l">
+              <a:lnSpc>
+                <a:spcPct val="115000"/>
+              </a:lnSpc>
+            </a:pPr>
+            <a:r>
+              <a:rPr sz="1300" b="0" i="0">
+                <a:solidFill>
+                  <a:srgbClr val="000000"/>
+                </a:solidFill>
+                <a:latin typeface="Georgia"/>
+              </a:rPr>
+              <a:t>[3] Apellido, N., Apellido, N. &amp; Apellido, N. (Año). Título del artículo. Revista, vol(núm), páginas.</a:t>
+            </a:r>
+          </a:p>
+        </p:txBody>
+      </p:sp>
+      <p:sp>
+        <p:nvSpPr>
+          <p:cNvPr id="38" name="Round Diagonal Corner Rectangle 37"/>
           <p:cNvSpPr/>
           <p:nvPr/>
         </p:nvSpPr>
         <p:spPr>
           <a:xfrm>
-            <a:off x="1260000" y="23508000"/>
-            <a:ext cx="13068000" cy="3888000"/>
-          </a:xfrm>
-          <a:prstGeom prst="rect">
-            <a:avLst/>
+            <a:off x="15588000" y="33660000"/>
+            <a:ext cx="14148000" cy="2700000"/>
+          </a:xfrm>
+          <a:prstGeom prst="round2DiagRect">
+            <a:avLst>
+              <a:gd name="adj1" fmla="val 9333"/>
+              <a:gd name="adj2" fmla="val 9333"/>
+            </a:avLst>
           </a:prstGeom>
-          <a:noFill/>
-          <a:ln w="12700">
+          <a:solidFill>
+            <a:srgbClr val="FFFFFF"/>
+          </a:solidFill>
+          <a:ln w="25400">
             <a:solidFill>
-              <a:srgbClr val="999999"/>
+              <a:srgbClr val="F7C59F"/>
             </a:solidFill>
-            <a:prstDash val="dash"/>
           </a:ln>
           <a:effectLst/>
         </p:spPr>
@@ -4071,43 +5326,146 @@
           </a:fontRef>
         </p:style>
         <p:txBody>
-          <a:bodyPr rtlCol="0" anchor="ctr" wrap="square"/>
+          <a:bodyPr rtlCol="0" anchor="ctr"/>
           <a:lstStyle/>
           <a:p>
             <a:pPr algn="ctr"/>
-            <a:r>
-              <a:rPr sz="1500" i="1">
-                <a:solidFill>
-                  <a:srgbClr val="777777"/>
+          </a:p>
+        </p:txBody>
+      </p:sp>
+      <p:sp>
+        <p:nvSpPr>
+          <p:cNvPr id="39" name="TextBox 38"/>
+          <p:cNvSpPr txBox="1"/>
+          <p:nvPr/>
+        </p:nvSpPr>
+        <p:spPr>
+          <a:xfrm>
+            <a:off x="16092000" y="34164000"/>
+            <a:ext cx="13140000" cy="720000"/>
+          </a:xfrm>
+          <a:prstGeom prst="rect">
+            <a:avLst/>
+          </a:prstGeom>
+          <a:noFill/>
+        </p:spPr>
+        <p:txBody>
+          <a:bodyPr wrap="square">
+            <a:spAutoFit/>
+          </a:bodyPr>
+          <a:lstStyle/>
+          <a:p>
+            <a:pPr algn="l">
+              <a:lnSpc>
+                <a:spcPct val="115000"/>
+              </a:lnSpc>
+            </a:pPr>
+            <a:r>
+              <a:rPr sz="2800" b="1" i="0">
+                <a:solidFill>
+                  <a:srgbClr val="1C6EA8"/>
                 </a:solidFill>
                 <a:latin typeface="Arial"/>
               </a:rPr>
-              <a:t>Espacio para ecuacion, diagrama de flujo
-o esquema del modelo</a:t>
-            </a:r>
-          </a:p>
-        </p:txBody>
-      </p:sp>
-      <p:sp>
-        <p:nvSpPr>
-          <p:cNvPr id="22" name="Rectangle 21"/>
+              <a:t>Agradecimientos</a:t>
+            </a:r>
+          </a:p>
+        </p:txBody>
+      </p:sp>
+      <p:sp>
+        <p:nvSpPr>
+          <p:cNvPr id="40" name="TextBox 39"/>
+          <p:cNvSpPr txBox="1"/>
+          <p:nvPr/>
+        </p:nvSpPr>
+        <p:spPr>
+          <a:xfrm>
+            <a:off x="16092000" y="35100000"/>
+            <a:ext cx="13140000" cy="756000"/>
+          </a:xfrm>
+          <a:prstGeom prst="rect">
+            <a:avLst/>
+          </a:prstGeom>
+          <a:noFill/>
+        </p:spPr>
+        <p:txBody>
+          <a:bodyPr wrap="square">
+            <a:spAutoFit/>
+          </a:bodyPr>
+          <a:lstStyle/>
+          <a:p>
+            <a:pPr algn="l">
+              <a:lnSpc>
+                <a:spcPct val="115000"/>
+              </a:lnSpc>
+            </a:pPr>
+            <a:r>
+              <a:rPr sz="1500" b="0" i="0">
+                <a:solidFill>
+                  <a:srgbClr val="000000"/>
+                </a:solidFill>
+                <a:latin typeface="Georgia"/>
+              </a:rPr>
+              <a:t>Financiamiento, institución o colegas a reconocer.</a:t>
+            </a:r>
+          </a:p>
+          <a:p>
+            <a:pPr algn="l">
+              <a:lnSpc>
+                <a:spcPct val="115000"/>
+              </a:lnSpc>
+            </a:pPr>
+            <a:r>
+              <a:rPr sz="1500" b="0" i="0">
+                <a:solidFill>
+                  <a:srgbClr val="000000"/>
+                </a:solidFill>
+                <a:latin typeface="Georgia"/>
+              </a:rPr>
+              <a:t/>
+            </a:r>
+          </a:p>
+          <a:p>
+            <a:pPr algn="l">
+              <a:lnSpc>
+                <a:spcPct val="115000"/>
+              </a:lnSpc>
+            </a:pPr>
+            <a:r>
+              <a:rPr sz="1500" b="0" i="0">
+                <a:solidFill>
+                  <a:srgbClr val="000000"/>
+                </a:solidFill>
+                <a:latin typeface="Georgia"/>
+              </a:rPr>
+              <a:t>Ut enim ad minim veniam, quis nostrud exercitation ullamco laboris nisi ut aliquip ex ea commodo consequat.</a:t>
+            </a:r>
+          </a:p>
+        </p:txBody>
+      </p:sp>
+      <p:sp>
+        <p:nvSpPr>
+          <p:cNvPr id="41" name="Round Diagonal Corner Rectangle 40"/>
           <p:cNvSpPr/>
           <p:nvPr/>
         </p:nvSpPr>
         <p:spPr>
           <a:xfrm>
-            <a:off x="15588000" y="6300000"/>
-            <a:ext cx="13788000" cy="14040000"/>
-          </a:xfrm>
-          <a:prstGeom prst="rect">
-            <a:avLst/>
+            <a:off x="540000" y="39024000"/>
+            <a:ext cx="29196000" cy="3240000"/>
+          </a:xfrm>
+          <a:prstGeom prst="round2DiagRect">
+            <a:avLst>
+              <a:gd name="adj1" fmla="val 7777"/>
+              <a:gd name="adj2" fmla="val 7777"/>
+            </a:avLst>
           </a:prstGeom>
           <a:solidFill>
             <a:srgbClr val="FFFFFF"/>
           </a:solidFill>
           <a:ln w="25400">
             <a:solidFill>
-              <a:srgbClr val="003B49"/>
+              <a:srgbClr val="F7C59F"/>
             </a:solidFill>
           </a:ln>
           <a:effectLst/>
@@ -4136,474 +5494,14 @@
       </p:sp>
       <p:sp>
         <p:nvSpPr>
-          <p:cNvPr id="23" name="Rectangle 22"/>
-          <p:cNvSpPr/>
-          <p:nvPr/>
-        </p:nvSpPr>
-        <p:spPr>
-          <a:xfrm>
-            <a:off x="15588000" y="6300000"/>
-            <a:ext cx="13788000" cy="720000"/>
-          </a:xfrm>
-          <a:prstGeom prst="rect">
-            <a:avLst/>
-          </a:prstGeom>
-          <a:solidFill>
-            <a:srgbClr val="003B49"/>
-          </a:solidFill>
-          <a:ln w="25400">
-            <a:solidFill>
-              <a:srgbClr val="003B49"/>
-            </a:solidFill>
-          </a:ln>
-          <a:effectLst/>
-        </p:spPr>
-        <p:style>
-          <a:lnRef idx="1">
-            <a:schemeClr val="accent1"/>
-          </a:lnRef>
-          <a:fillRef idx="3">
-            <a:schemeClr val="accent1"/>
-          </a:fillRef>
-          <a:effectRef idx="2">
-            <a:schemeClr val="accent1"/>
-          </a:effectRef>
-          <a:fontRef idx="minor">
-            <a:schemeClr val="lt1"/>
-          </a:fontRef>
-        </p:style>
-        <p:txBody>
-          <a:bodyPr rtlCol="0" anchor="ctr"/>
-          <a:lstStyle/>
-          <a:p>
-            <a:pPr algn="ctr"/>
-          </a:p>
-        </p:txBody>
-      </p:sp>
-      <p:sp>
-        <p:nvSpPr>
-          <p:cNvPr id="24" name="TextBox 23"/>
+          <p:cNvPr id="42" name="TextBox 41"/>
           <p:cNvSpPr txBox="1"/>
           <p:nvPr/>
         </p:nvSpPr>
         <p:spPr>
           <a:xfrm>
-            <a:off x="15948000" y="6300000"/>
-            <a:ext cx="13068000" cy="720000"/>
-          </a:xfrm>
-          <a:prstGeom prst="rect">
-            <a:avLst/>
-          </a:prstGeom>
-          <a:noFill/>
-        </p:spPr>
-        <p:txBody>
-          <a:bodyPr wrap="square" anchor="ctr">
-            <a:spAutoFit/>
-          </a:bodyPr>
-          <a:lstStyle/>
-          <a:p>
-            <a:pPr algn="l">
-              <a:lnSpc>
-                <a:spcPct val="115000"/>
-              </a:lnSpc>
-            </a:pPr>
-            <a:r>
-              <a:rPr sz="2600" b="1" i="0">
-                <a:solidFill>
-                  <a:srgbClr val="FFFFFF"/>
-                </a:solidFill>
-                <a:latin typeface="Georgia"/>
-              </a:rPr>
-              <a:t>Resultados</a:t>
-            </a:r>
-          </a:p>
-        </p:txBody>
-      </p:sp>
-      <p:sp>
-        <p:nvSpPr>
-          <p:cNvPr id="25" name="TextBox 24"/>
-          <p:cNvSpPr txBox="1"/>
-          <p:nvPr/>
-        </p:nvSpPr>
-        <p:spPr>
-          <a:xfrm>
-            <a:off x="15948000" y="7380000"/>
-            <a:ext cx="13068000" cy="1080000"/>
-          </a:xfrm>
-          <a:prstGeom prst="rect">
-            <a:avLst/>
-          </a:prstGeom>
-          <a:noFill/>
-        </p:spPr>
-        <p:txBody>
-          <a:bodyPr wrap="square">
-            <a:spAutoFit/>
-          </a:bodyPr>
-          <a:lstStyle/>
-          <a:p>
-            <a:pPr algn="l">
-              <a:lnSpc>
-                <a:spcPct val="115000"/>
-              </a:lnSpc>
-            </a:pPr>
-            <a:r>
-              <a:rPr sz="1700" b="0" i="0">
-                <a:solidFill>
-                  <a:srgbClr val="202020"/>
-                </a:solidFill>
-                <a:latin typeface="Arial"/>
-              </a:rPr>
-              <a:t>Presente los resultados principales, apoyados en figuras y/o tablas.</a:t>
-            </a:r>
-          </a:p>
-        </p:txBody>
-      </p:sp>
-      <p:sp>
-        <p:nvSpPr>
-          <p:cNvPr id="26" name="Rectangle 25"/>
-          <p:cNvSpPr/>
-          <p:nvPr/>
-        </p:nvSpPr>
-        <p:spPr>
-          <a:xfrm>
-            <a:off x="15948000" y="8640000"/>
-            <a:ext cx="13068000" cy="7920000"/>
-          </a:xfrm>
-          <a:prstGeom prst="rect">
-            <a:avLst/>
-          </a:prstGeom>
-          <a:noFill/>
-          <a:ln w="12700">
-            <a:solidFill>
-              <a:srgbClr val="999999"/>
-            </a:solidFill>
-            <a:prstDash val="dash"/>
-          </a:ln>
-          <a:effectLst/>
-        </p:spPr>
-        <p:style>
-          <a:lnRef idx="1">
-            <a:schemeClr val="accent1"/>
-          </a:lnRef>
-          <a:fillRef idx="3">
-            <a:schemeClr val="accent1"/>
-          </a:fillRef>
-          <a:effectRef idx="2">
-            <a:schemeClr val="accent1"/>
-          </a:effectRef>
-          <a:fontRef idx="minor">
-            <a:schemeClr val="lt1"/>
-          </a:fontRef>
-        </p:style>
-        <p:txBody>
-          <a:bodyPr rtlCol="0" anchor="ctr" wrap="square"/>
-          <a:lstStyle/>
-          <a:p>
-            <a:pPr algn="ctr"/>
-            <a:r>
-              <a:rPr sz="1500" i="1">
-                <a:solidFill>
-                  <a:srgbClr val="777777"/>
-                </a:solidFill>
-                <a:latin typeface="Arial"/>
-              </a:rPr>
-              <a:t>Figura 1. Espacio para figura principal
-(grafico, mapa, simulacion, etc.)</a:t>
-            </a:r>
-          </a:p>
-        </p:txBody>
-      </p:sp>
-      <p:sp>
-        <p:nvSpPr>
-          <p:cNvPr id="27" name="Rectangle 26"/>
-          <p:cNvSpPr/>
-          <p:nvPr/>
-        </p:nvSpPr>
-        <p:spPr>
-          <a:xfrm>
-            <a:off x="15948000" y="16920000"/>
-            <a:ext cx="13068000" cy="3060000"/>
-          </a:xfrm>
-          <a:prstGeom prst="rect">
-            <a:avLst/>
-          </a:prstGeom>
-          <a:noFill/>
-          <a:ln w="12700">
-            <a:solidFill>
-              <a:srgbClr val="999999"/>
-            </a:solidFill>
-            <a:prstDash val="dash"/>
-          </a:ln>
-          <a:effectLst/>
-        </p:spPr>
-        <p:style>
-          <a:lnRef idx="1">
-            <a:schemeClr val="accent1"/>
-          </a:lnRef>
-          <a:fillRef idx="3">
-            <a:schemeClr val="accent1"/>
-          </a:fillRef>
-          <a:effectRef idx="2">
-            <a:schemeClr val="accent1"/>
-          </a:effectRef>
-          <a:fontRef idx="minor">
-            <a:schemeClr val="lt1"/>
-          </a:fontRef>
-        </p:style>
-        <p:txBody>
-          <a:bodyPr rtlCol="0" anchor="ctr" wrap="square"/>
-          <a:lstStyle/>
-          <a:p>
-            <a:pPr algn="ctr"/>
-            <a:r>
-              <a:rPr sz="1500" i="1">
-                <a:solidFill>
-                  <a:srgbClr val="777777"/>
-                </a:solidFill>
-                <a:latin typeface="Arial"/>
-              </a:rPr>
-              <a:t>Tabla 1. Espacio para tabla de resultados
-(parametro, valor, IC 95%, p)</a:t>
-            </a:r>
-          </a:p>
-        </p:txBody>
-      </p:sp>
-      <p:sp>
-        <p:nvSpPr>
-          <p:cNvPr id="28" name="Rectangle 27"/>
-          <p:cNvSpPr/>
-          <p:nvPr/>
-        </p:nvSpPr>
-        <p:spPr>
-          <a:xfrm>
-            <a:off x="15588000" y="20988000"/>
-            <a:ext cx="13788000" cy="7200000"/>
-          </a:xfrm>
-          <a:prstGeom prst="rect">
-            <a:avLst/>
-          </a:prstGeom>
-          <a:solidFill>
-            <a:srgbClr val="FFFFFF"/>
-          </a:solidFill>
-          <a:ln w="25400">
-            <a:solidFill>
-              <a:srgbClr val="003B49"/>
-            </a:solidFill>
-          </a:ln>
-          <a:effectLst/>
-        </p:spPr>
-        <p:style>
-          <a:lnRef idx="1">
-            <a:schemeClr val="accent1"/>
-          </a:lnRef>
-          <a:fillRef idx="3">
-            <a:schemeClr val="accent1"/>
-          </a:fillRef>
-          <a:effectRef idx="2">
-            <a:schemeClr val="accent1"/>
-          </a:effectRef>
-          <a:fontRef idx="minor">
-            <a:schemeClr val="lt1"/>
-          </a:fontRef>
-        </p:style>
-        <p:txBody>
-          <a:bodyPr rtlCol="0" anchor="ctr"/>
-          <a:lstStyle/>
-          <a:p>
-            <a:pPr algn="ctr"/>
-          </a:p>
-        </p:txBody>
-      </p:sp>
-      <p:sp>
-        <p:nvSpPr>
-          <p:cNvPr id="29" name="Rectangle 28"/>
-          <p:cNvSpPr/>
-          <p:nvPr/>
-        </p:nvSpPr>
-        <p:spPr>
-          <a:xfrm>
-            <a:off x="15588000" y="20988000"/>
-            <a:ext cx="13788000" cy="720000"/>
-          </a:xfrm>
-          <a:prstGeom prst="rect">
-            <a:avLst/>
-          </a:prstGeom>
-          <a:solidFill>
-            <a:srgbClr val="003B49"/>
-          </a:solidFill>
-          <a:ln w="25400">
-            <a:solidFill>
-              <a:srgbClr val="003B49"/>
-            </a:solidFill>
-          </a:ln>
-          <a:effectLst/>
-        </p:spPr>
-        <p:style>
-          <a:lnRef idx="1">
-            <a:schemeClr val="accent1"/>
-          </a:lnRef>
-          <a:fillRef idx="3">
-            <a:schemeClr val="accent1"/>
-          </a:fillRef>
-          <a:effectRef idx="2">
-            <a:schemeClr val="accent1"/>
-          </a:effectRef>
-          <a:fontRef idx="minor">
-            <a:schemeClr val="lt1"/>
-          </a:fontRef>
-        </p:style>
-        <p:txBody>
-          <a:bodyPr rtlCol="0" anchor="ctr"/>
-          <a:lstStyle/>
-          <a:p>
-            <a:pPr algn="ctr"/>
-          </a:p>
-        </p:txBody>
-      </p:sp>
-      <p:sp>
-        <p:nvSpPr>
-          <p:cNvPr id="30" name="TextBox 29"/>
-          <p:cNvSpPr txBox="1"/>
-          <p:nvPr/>
-        </p:nvSpPr>
-        <p:spPr>
-          <a:xfrm>
-            <a:off x="15948000" y="20988000"/>
-            <a:ext cx="13068000" cy="720000"/>
-          </a:xfrm>
-          <a:prstGeom prst="rect">
-            <a:avLst/>
-          </a:prstGeom>
-          <a:noFill/>
-        </p:spPr>
-        <p:txBody>
-          <a:bodyPr wrap="square" anchor="ctr">
-            <a:spAutoFit/>
-          </a:bodyPr>
-          <a:lstStyle/>
-          <a:p>
-            <a:pPr algn="l">
-              <a:lnSpc>
-                <a:spcPct val="115000"/>
-              </a:lnSpc>
-            </a:pPr>
-            <a:r>
-              <a:rPr sz="2600" b="1" i="0">
-                <a:solidFill>
-                  <a:srgbClr val="FFFFFF"/>
-                </a:solidFill>
-                <a:latin typeface="Georgia"/>
-              </a:rPr>
-              <a:t>Referencias</a:t>
-            </a:r>
-          </a:p>
-        </p:txBody>
-      </p:sp>
-      <p:sp>
-        <p:nvSpPr>
-          <p:cNvPr id="31" name="TextBox 30"/>
-          <p:cNvSpPr txBox="1"/>
-          <p:nvPr/>
-        </p:nvSpPr>
-        <p:spPr>
-          <a:xfrm>
-            <a:off x="15948000" y="22068000"/>
-            <a:ext cx="10368000" cy="5760000"/>
-          </a:xfrm>
-          <a:prstGeom prst="rect">
-            <a:avLst/>
-          </a:prstGeom>
-          <a:noFill/>
-        </p:spPr>
-        <p:txBody>
-          <a:bodyPr wrap="square">
-            <a:spAutoFit/>
-          </a:bodyPr>
-          <a:lstStyle/>
-          <a:p>
-            <a:pPr algn="l">
-              <a:lnSpc>
-                <a:spcPct val="115000"/>
-              </a:lnSpc>
-            </a:pPr>
-            <a:r>
-              <a:rPr sz="1500" b="0" i="0">
-                <a:solidFill>
-                  <a:srgbClr val="202020"/>
-                </a:solidFill>
-                <a:latin typeface="Arial"/>
-              </a:rPr>
-              <a:t>[1] Apellido, N. (Ano). Titulo del articulo. Revista, vol(num), paginas.</a:t>
-            </a:r>
-          </a:p>
-          <a:p>
-            <a:pPr algn="l">
-              <a:lnSpc>
-                <a:spcPct val="115000"/>
-              </a:lnSpc>
-            </a:pPr>
-            <a:r>
-              <a:rPr sz="1500" b="0" i="0">
-                <a:solidFill>
-                  <a:srgbClr val="202020"/>
-                </a:solidFill>
-                <a:latin typeface="Arial"/>
-              </a:rPr>
-              <a:t/>
-            </a:r>
-          </a:p>
-          <a:p>
-            <a:pPr algn="l">
-              <a:lnSpc>
-                <a:spcPct val="115000"/>
-              </a:lnSpc>
-            </a:pPr>
-            <a:r>
-              <a:rPr sz="1500" b="0" i="0">
-                <a:solidFill>
-                  <a:srgbClr val="202020"/>
-                </a:solidFill>
-                <a:latin typeface="Arial"/>
-              </a:rPr>
-              <a:t>[2] Apellido, N. &amp; Apellido, N. (Ano). Titulo del articulo. Revista, vol(num), paginas.</a:t>
-            </a:r>
-          </a:p>
-        </p:txBody>
-      </p:sp>
-      <p:pic>
-        <p:nvPicPr>
-          <p:cNvPr id="32" name="Picture 31" descr="_qr_solabima2026.png"/>
-          <p:cNvPicPr>
-            <a:picLocks noChangeAspect="1"/>
-          </p:cNvPicPr>
-          <p:nvPr/>
-        </p:nvPicPr>
-        <p:blipFill>
-          <a:blip r:embed="rId2"/>
-          <a:stretch>
-            <a:fillRect/>
-          </a:stretch>
-        </p:blipFill>
-        <p:spPr>
-          <a:xfrm>
-            <a:off x="26856000" y="22068000"/>
-            <a:ext cx="2160000" cy="2160000"/>
-          </a:xfrm>
-          <a:prstGeom prst="rect">
-            <a:avLst/>
-          </a:prstGeom>
-        </p:spPr>
-      </p:pic>
-      <p:sp>
-        <p:nvSpPr>
-          <p:cNvPr id="33" name="TextBox 32"/>
-          <p:cNvSpPr txBox="1"/>
-          <p:nvPr/>
-        </p:nvSpPr>
-        <p:spPr>
-          <a:xfrm>
-            <a:off x="26496000" y="24300000"/>
-            <a:ext cx="2880000" cy="720000"/>
+            <a:off x="1044000" y="39528000"/>
+            <a:ext cx="28188000" cy="576000"/>
           </a:xfrm>
           <a:prstGeom prst="rect">
             <a:avLst/>
@@ -4622,339 +5520,20 @@
               </a:lnSpc>
             </a:pPr>
             <a:r>
-              <a:rPr sz="1200" b="0" i="0">
-                <a:solidFill>
-                  <a:srgbClr val="202020"/>
-                </a:solidFill>
-                <a:latin typeface="Arial"/>
-              </a:rPr>
-              <a:t>Escanee para mas</a:t>
-            </a:r>
-          </a:p>
-          <a:p>
-            <a:pPr algn="ctr">
-              <a:lnSpc>
-                <a:spcPct val="115000"/>
-              </a:lnSpc>
-            </a:pPr>
-            <a:r>
-              <a:rPr sz="1200" b="0" i="0">
-                <a:solidFill>
-                  <a:srgbClr val="202020"/>
-                </a:solidFill>
-                <a:latin typeface="Arial"/>
-              </a:rPr>
-              <a:t>informacion</a:t>
-            </a:r>
-          </a:p>
-        </p:txBody>
-      </p:sp>
-      <p:sp>
-        <p:nvSpPr>
-          <p:cNvPr id="34" name="Rectangle 33"/>
-          <p:cNvSpPr/>
-          <p:nvPr/>
-        </p:nvSpPr>
-        <p:spPr>
-          <a:xfrm>
-            <a:off x="15588000" y="28836000"/>
-            <a:ext cx="13788000" cy="3600000"/>
-          </a:xfrm>
-          <a:prstGeom prst="rect">
-            <a:avLst/>
-          </a:prstGeom>
-          <a:solidFill>
-            <a:srgbClr val="FFFFFF"/>
-          </a:solidFill>
-          <a:ln w="25400">
-            <a:solidFill>
-              <a:srgbClr val="003B49"/>
-            </a:solidFill>
-          </a:ln>
-          <a:effectLst/>
-        </p:spPr>
-        <p:style>
-          <a:lnRef idx="1">
-            <a:schemeClr val="accent1"/>
-          </a:lnRef>
-          <a:fillRef idx="3">
-            <a:schemeClr val="accent1"/>
-          </a:fillRef>
-          <a:effectRef idx="2">
-            <a:schemeClr val="accent1"/>
-          </a:effectRef>
-          <a:fontRef idx="minor">
-            <a:schemeClr val="lt1"/>
-          </a:fontRef>
-        </p:style>
-        <p:txBody>
-          <a:bodyPr rtlCol="0" anchor="ctr"/>
-          <a:lstStyle/>
-          <a:p>
-            <a:pPr algn="ctr"/>
-          </a:p>
-        </p:txBody>
-      </p:sp>
-      <p:sp>
-        <p:nvSpPr>
-          <p:cNvPr id="35" name="Rectangle 34"/>
-          <p:cNvSpPr/>
-          <p:nvPr/>
-        </p:nvSpPr>
-        <p:spPr>
-          <a:xfrm>
-            <a:off x="15588000" y="28836000"/>
-            <a:ext cx="13788000" cy="720000"/>
-          </a:xfrm>
-          <a:prstGeom prst="rect">
-            <a:avLst/>
-          </a:prstGeom>
-          <a:solidFill>
-            <a:srgbClr val="003B49"/>
-          </a:solidFill>
-          <a:ln w="25400">
-            <a:solidFill>
-              <a:srgbClr val="003B49"/>
-            </a:solidFill>
-          </a:ln>
-          <a:effectLst/>
-        </p:spPr>
-        <p:style>
-          <a:lnRef idx="1">
-            <a:schemeClr val="accent1"/>
-          </a:lnRef>
-          <a:fillRef idx="3">
-            <a:schemeClr val="accent1"/>
-          </a:fillRef>
-          <a:effectRef idx="2">
-            <a:schemeClr val="accent1"/>
-          </a:effectRef>
-          <a:fontRef idx="minor">
-            <a:schemeClr val="lt1"/>
-          </a:fontRef>
-        </p:style>
-        <p:txBody>
-          <a:bodyPr rtlCol="0" anchor="ctr"/>
-          <a:lstStyle/>
-          <a:p>
-            <a:pPr algn="ctr"/>
-          </a:p>
-        </p:txBody>
-      </p:sp>
-      <p:sp>
-        <p:nvSpPr>
-          <p:cNvPr id="36" name="TextBox 35"/>
-          <p:cNvSpPr txBox="1"/>
-          <p:nvPr/>
-        </p:nvSpPr>
-        <p:spPr>
-          <a:xfrm>
-            <a:off x="15948000" y="28836000"/>
-            <a:ext cx="13068000" cy="720000"/>
-          </a:xfrm>
-          <a:prstGeom prst="rect">
-            <a:avLst/>
-          </a:prstGeom>
-          <a:noFill/>
-        </p:spPr>
-        <p:txBody>
-          <a:bodyPr wrap="square" anchor="ctr">
-            <a:spAutoFit/>
-          </a:bodyPr>
-          <a:lstStyle/>
-          <a:p>
-            <a:pPr algn="l">
-              <a:lnSpc>
-                <a:spcPct val="115000"/>
-              </a:lnSpc>
-            </a:pPr>
-            <a:r>
-              <a:rPr sz="2600" b="1" i="0">
-                <a:solidFill>
-                  <a:srgbClr val="FFFFFF"/>
+              <a:rPr sz="1500" b="0" i="1">
+                <a:solidFill>
+                  <a:srgbClr val="333333"/>
                 </a:solidFill>
                 <a:latin typeface="Georgia"/>
               </a:rPr>
-              <a:t>Agradecimientos</a:t>
-            </a:r>
-          </a:p>
-        </p:txBody>
-      </p:sp>
-      <p:sp>
-        <p:nvSpPr>
-          <p:cNvPr id="37" name="TextBox 36"/>
-          <p:cNvSpPr txBox="1"/>
-          <p:nvPr/>
-        </p:nvSpPr>
-        <p:spPr>
-          <a:xfrm>
-            <a:off x="15948000" y="29916000"/>
-            <a:ext cx="13068000" cy="2160000"/>
-          </a:xfrm>
-          <a:prstGeom prst="rect">
-            <a:avLst/>
-          </a:prstGeom>
-          <a:noFill/>
-        </p:spPr>
-        <p:txBody>
-          <a:bodyPr wrap="square">
-            <a:spAutoFit/>
-          </a:bodyPr>
-          <a:lstStyle/>
-          <a:p>
-            <a:pPr algn="l">
-              <a:lnSpc>
-                <a:spcPct val="115000"/>
-              </a:lnSpc>
-            </a:pPr>
-            <a:r>
-              <a:rPr sz="1700" b="0" i="0">
-                <a:solidFill>
-                  <a:srgbClr val="202020"/>
-                </a:solidFill>
-                <a:latin typeface="Arial"/>
-              </a:rPr>
-              <a:t>Financiamiento, institucion o colegas a reconocer.</a:t>
-            </a:r>
-          </a:p>
-        </p:txBody>
-      </p:sp>
-      <p:sp>
-        <p:nvSpPr>
-          <p:cNvPr id="38" name="Rectangle 37"/>
-          <p:cNvSpPr/>
-          <p:nvPr/>
-        </p:nvSpPr>
-        <p:spPr>
-          <a:xfrm>
-            <a:off x="900000" y="33336000"/>
-            <a:ext cx="28476000" cy="5040000"/>
-          </a:xfrm>
-          <a:prstGeom prst="rect">
-            <a:avLst/>
-          </a:prstGeom>
-          <a:solidFill>
-            <a:srgbClr val="FFFFFF"/>
-          </a:solidFill>
-          <a:ln w="25400">
-            <a:solidFill>
-              <a:srgbClr val="003B49"/>
-            </a:solidFill>
-          </a:ln>
-          <a:effectLst/>
-        </p:spPr>
-        <p:style>
-          <a:lnRef idx="1">
-            <a:schemeClr val="accent1"/>
-          </a:lnRef>
-          <a:fillRef idx="3">
-            <a:schemeClr val="accent1"/>
-          </a:fillRef>
-          <a:effectRef idx="2">
-            <a:schemeClr val="accent1"/>
-          </a:effectRef>
-          <a:fontRef idx="minor">
-            <a:schemeClr val="lt1"/>
-          </a:fontRef>
-        </p:style>
-        <p:txBody>
-          <a:bodyPr rtlCol="0" anchor="ctr"/>
-          <a:lstStyle/>
-          <a:p>
-            <a:pPr algn="ctr"/>
-          </a:p>
-        </p:txBody>
-      </p:sp>
-      <p:sp>
-        <p:nvSpPr>
-          <p:cNvPr id="39" name="TextBox 38"/>
-          <p:cNvSpPr txBox="1"/>
-          <p:nvPr/>
-        </p:nvSpPr>
-        <p:spPr>
-          <a:xfrm>
-            <a:off x="900000" y="33768000"/>
-            <a:ext cx="28476000" cy="504000"/>
-          </a:xfrm>
-          <a:prstGeom prst="rect">
-            <a:avLst/>
-          </a:prstGeom>
-          <a:noFill/>
-        </p:spPr>
-        <p:txBody>
-          <a:bodyPr wrap="square">
-            <a:spAutoFit/>
-          </a:bodyPr>
-          <a:lstStyle/>
-          <a:p>
-            <a:pPr algn="ctr">
-              <a:lnSpc>
-                <a:spcPct val="115000"/>
-              </a:lnSpc>
-            </a:pPr>
-            <a:r>
-              <a:rPr sz="1500" b="1" i="0">
-                <a:solidFill>
-                  <a:srgbClr val="003B49"/>
-                </a:solidFill>
-                <a:latin typeface="Arial"/>
-              </a:rPr>
-              <a:t>INSTITUCIONES ORGANIZADORAS Y AUSPICIANTES</a:t>
+              <a:t>Esta franja es opcional: puede usarla para agregar más logos, información adicional, un código QR, etc., o eliminarla por completo si no la necesita.</a:t>
             </a:r>
           </a:p>
         </p:txBody>
       </p:sp>
       <p:pic>
         <p:nvPicPr>
-          <p:cNvPr id="40" name="Picture 39" descr="logo_solabima.png"/>
-          <p:cNvPicPr>
-            <a:picLocks noChangeAspect="1"/>
-          </p:cNvPicPr>
-          <p:nvPr/>
-        </p:nvPicPr>
-        <p:blipFill>
-          <a:blip r:embed="rId3"/>
-          <a:stretch>
-            <a:fillRect/>
-          </a:stretch>
-        </p:blipFill>
-        <p:spPr>
-          <a:xfrm>
-            <a:off x="4068000" y="36036000"/>
-            <a:ext cx="4050000" cy="1620000"/>
-          </a:xfrm>
-          <a:prstGeom prst="rect">
-            <a:avLst/>
-          </a:prstGeom>
-        </p:spPr>
-      </p:pic>
-      <p:pic>
-        <p:nvPicPr>
-          <p:cNvPr id="41" name="Picture 40" descr="logo_una.png"/>
-          <p:cNvPicPr>
-            <a:picLocks noChangeAspect="1"/>
-          </p:cNvPicPr>
-          <p:nvPr/>
-        </p:nvPicPr>
-        <p:blipFill>
-          <a:blip r:embed="rId4"/>
-          <a:stretch>
-            <a:fillRect/>
-          </a:stretch>
-        </p:blipFill>
-        <p:spPr>
-          <a:xfrm>
-            <a:off x="7848000" y="36036000"/>
-            <a:ext cx="4050000" cy="1620000"/>
-          </a:xfrm>
-          <a:prstGeom prst="rect">
-            <a:avLst/>
-          </a:prstGeom>
-        </p:spPr>
-      </p:pic>
-      <p:pic>
-        <p:nvPicPr>
-          <p:cNvPr id="42" name="Picture 41" descr="logo_fpuna.png"/>
+          <p:cNvPr id="43" name="Picture 42" descr="logo_custom1.png"/>
           <p:cNvPicPr>
             <a:picLocks noChangeAspect="1"/>
           </p:cNvPicPr>
@@ -4968,32 +5547,8 @@
         </p:blipFill>
         <p:spPr>
           <a:xfrm>
-            <a:off x="11628000" y="36036000"/>
-            <a:ext cx="4050000" cy="1620000"/>
-          </a:xfrm>
-          <a:prstGeom prst="rect">
-            <a:avLst/>
-          </a:prstGeom>
-        </p:spPr>
-      </p:pic>
-      <p:pic>
-        <p:nvPicPr>
-          <p:cNvPr id="43" name="Picture 42" descr="logo_arasy.png"/>
-          <p:cNvPicPr>
-            <a:picLocks noChangeAspect="1"/>
-          </p:cNvPicPr>
-          <p:nvPr/>
-        </p:nvPicPr>
-        <p:blipFill>
-          <a:blip r:embed="rId6"/>
-          <a:stretch>
-            <a:fillRect/>
-          </a:stretch>
-        </p:blipFill>
-        <p:spPr>
-          <a:xfrm>
-            <a:off x="15408000" y="36036000"/>
-            <a:ext cx="4050000" cy="1620000"/>
+            <a:off x="12117000" y="39780000"/>
+            <a:ext cx="2805000" cy="1980000"/>
           </a:xfrm>
           <a:prstGeom prst="rect">
             <a:avLst/>
@@ -5009,39 +5564,15 @@
           <p:nvPr/>
         </p:nvPicPr>
         <p:blipFill>
-          <a:blip r:embed="rId7"/>
+          <a:blip r:embed="rId5"/>
           <a:stretch>
             <a:fillRect/>
           </a:stretch>
         </p:blipFill>
         <p:spPr>
           <a:xfrm>
-            <a:off x="19188000" y="36036000"/>
-            <a:ext cx="4050000" cy="1620000"/>
-          </a:xfrm>
-          <a:prstGeom prst="rect">
-            <a:avLst/>
-          </a:prstGeom>
-        </p:spPr>
-      </p:pic>
-      <p:pic>
-        <p:nvPicPr>
-          <p:cNvPr id="45" name="Picture 44" descr="logo_custom1.png"/>
-          <p:cNvPicPr>
-            <a:picLocks noChangeAspect="1"/>
-          </p:cNvPicPr>
-          <p:nvPr/>
-        </p:nvPicPr>
-        <p:blipFill>
-          <a:blip r:embed="rId7"/>
-          <a:stretch>
-            <a:fillRect/>
-          </a:stretch>
-        </p:blipFill>
-        <p:spPr>
-          <a:xfrm>
-            <a:off x="22968000" y="36036000"/>
-            <a:ext cx="4050000" cy="1620000"/>
+            <a:off x="15354000" y="39780000"/>
+            <a:ext cx="2805000" cy="1980000"/>
           </a:xfrm>
           <a:prstGeom prst="rect">
             <a:avLst/>

</xml_diff>

<commit_message>
Manual PPTX touch-ups: 2-line title, author/caption text tweaks
Co-Authored-By: Claude Sonnet 5 <noreply@anthropic.com>
</commit_message>
<xml_diff>
--- a/pptx/solabima2026_poster_template.pptx
+++ b/pptx/solabima2026_poster_template.pptx
@@ -3223,7 +3223,7 @@
         <p:spPr>
           <a:xfrm>
             <a:off x="4919006" y="5524195"/>
-            <a:ext cx="20437199" cy="584200"/>
+            <a:ext cx="20437199" cy="649665"/>
           </a:xfrm>
           <a:prstGeom prst="rect">
             <a:avLst/>
@@ -3248,8 +3248,32 @@
                 </a:solidFill>
                 <a:latin typeface="Georgia"/>
               </a:rPr>
-              <a:t>Nombre Apellido¹, Nombre Apellido², Nombre Apellido¹,*</a:t>
-            </a:r>
+              <a:t>Nombre Apellido¹, Nombre Apellido², Nombre </a:t>
+            </a:r>
+            <a:r>
+              <a:rPr sz="4000" b="0" i="0" dirty="0" err="1">
+                <a:solidFill>
+                  <a:srgbClr val="333333"/>
+                </a:solidFill>
+                <a:latin typeface="Georgia"/>
+              </a:rPr>
+              <a:t>Apellido</a:t>
+            </a:r>
+            <a:r>
+              <a:rPr lang="en-NO" sz="4000" b="0" i="0" dirty="0">
+                <a:solidFill>
+                  <a:srgbClr val="333333"/>
+                </a:solidFill>
+                <a:latin typeface="Georgia"/>
+              </a:rPr>
+              <a:t>¹*</a:t>
+            </a:r>
+            <a:endParaRPr sz="4000" b="0" i="0" dirty="0">
+              <a:solidFill>
+                <a:srgbClr val="333333"/>
+              </a:solidFill>
+              <a:latin typeface="Georgia"/>
+            </a:endParaRPr>
           </a:p>
         </p:txBody>
       </p:sp>

</xml_diff>

<commit_message>
Fix header asymmetry: recenter title and flanking logos
The title textbox and both logos had drifted from their originally
symmetric positions (title +6mm, badge +21mm, right logo -33mm - an
uneven combination, not a deliberate resymmetrization). Recomputed
each element's position from the same centered-zone formula the
generator uses, so the header is precisely symmetric again.

Co-Authored-By: Claude Sonnet 5 <noreply@anthropic.com>
</commit_message>
<xml_diff>
--- a/pptx/solabima2026_poster_template.pptx
+++ b/pptx/solabima2026_poster_template.pptx
@@ -3098,7 +3098,7 @@
         </p:nvSpPr>
         <p:spPr>
           <a:xfrm>
-            <a:off x="5135400" y="1415981"/>
+            <a:off x="4919006" y="1415981"/>
             <a:ext cx="20437199" cy="2440027"/>
           </a:xfrm>
           <a:prstGeom prst="rect">
@@ -3502,7 +3502,7 @@
         </p:blipFill>
         <p:spPr>
           <a:xfrm>
-            <a:off x="1329000" y="2873963"/>
+            <a:off x="584503" y="2873963"/>
             <a:ext cx="4290000" cy="4680000"/>
           </a:xfrm>
           <a:prstGeom prst="rect">
@@ -3526,7 +3526,7 @@
         </p:blipFill>
         <p:spPr>
           <a:xfrm>
-            <a:off x="24198929" y="4000009"/>
+            <a:off x="25378208" y="4000009"/>
             <a:ext cx="4335000" cy="3060000"/>
           </a:xfrm>
           <a:prstGeom prst="rect">

</xml_diff>

<commit_message>
Bring header logos 40mm closer to the title, symmetrically
Co-Authored-By: Claude Sonnet 5 <noreply@anthropic.com>
</commit_message>
<xml_diff>
--- a/pptx/solabima2026_poster_template.pptx
+++ b/pptx/solabima2026_poster_template.pptx
@@ -3502,7 +3502,7 @@
         </p:blipFill>
         <p:spPr>
           <a:xfrm>
-            <a:off x="584503" y="2873963"/>
+            <a:off x="2024503" y="2873963"/>
             <a:ext cx="4290000" cy="4680000"/>
           </a:xfrm>
           <a:prstGeom prst="rect">
@@ -3526,7 +3526,7 @@
         </p:blipFill>
         <p:spPr>
           <a:xfrm>
-            <a:off x="25378208" y="4000009"/>
+            <a:off x="23938208" y="4000009"/>
             <a:ext cx="4335000" cy="3060000"/>
           </a:xfrm>
           <a:prstGeom prst="rect">

</xml_diff>